<commit_message>
docs: refresh resume and portfolio engineering cases
</commit_message>
<xml_diff>
--- a/public/downloads/heetae-lee-portfolio.pptx
+++ b/public/downloads/heetae-lee-portfolio.pptx
@@ -2,24 +2,24 @@
 <file path=ppt/presentation.xml><?xml version="1.0" encoding="utf-8"?>
 <p:presentation xmlns:p="http://schemas.openxmlformats.org/presentationml/2006/main">
   <p:sldMasterIdLst>
-    <p:sldMasterId xmlns:r="http://schemas.openxmlformats.org/officeDocument/2006/relationships" id="2147483648" r:id="Rcdcec6946f914e88"/>
+    <p:sldMasterId xmlns:r="http://schemas.openxmlformats.org/officeDocument/2006/relationships" id="2147483648" r:id="R3563b7c7620046a9"/>
   </p:sldMasterIdLst>
   <p:notesMasterIdLst>
-    <p:notesMasterId xmlns:r="http://schemas.openxmlformats.org/officeDocument/2006/relationships" r:id="R593c42fca64e45e1"/>
+    <p:notesMasterId xmlns:r="http://schemas.openxmlformats.org/officeDocument/2006/relationships" r:id="Rc78c8d66333e41bb"/>
   </p:notesMasterIdLst>
   <p:sldIdLst>
-    <p:sldId xmlns:r="http://schemas.openxmlformats.org/officeDocument/2006/relationships" id="256" r:id="R623a2c9c398f429d"/>
-    <p:sldId xmlns:r="http://schemas.openxmlformats.org/officeDocument/2006/relationships" id="257" r:id="R33f276062b5d42da"/>
-    <p:sldId xmlns:r="http://schemas.openxmlformats.org/officeDocument/2006/relationships" id="258" r:id="R9254ab30e5544fb2"/>
-    <p:sldId xmlns:r="http://schemas.openxmlformats.org/officeDocument/2006/relationships" id="259" r:id="Red8716ffd4e04324"/>
-    <p:sldId xmlns:r="http://schemas.openxmlformats.org/officeDocument/2006/relationships" id="260" r:id="R11167adb38ff4711"/>
-    <p:sldId xmlns:r="http://schemas.openxmlformats.org/officeDocument/2006/relationships" id="261" r:id="R8e9399cc8b6342e9"/>
-    <p:sldId xmlns:r="http://schemas.openxmlformats.org/officeDocument/2006/relationships" id="262" r:id="Re7f9ee85dc91445f"/>
-    <p:sldId xmlns:r="http://schemas.openxmlformats.org/officeDocument/2006/relationships" id="263" r:id="Ra1b6a7fe7cc44d4e"/>
-    <p:sldId xmlns:r="http://schemas.openxmlformats.org/officeDocument/2006/relationships" id="264" r:id="R33c5dd1f6218472c"/>
-    <p:sldId xmlns:r="http://schemas.openxmlformats.org/officeDocument/2006/relationships" id="265" r:id="R4ca92e1fdb6d47e2"/>
-    <p:sldId xmlns:r="http://schemas.openxmlformats.org/officeDocument/2006/relationships" id="266" r:id="R3cf85b5d7cb245f0"/>
-    <p:sldId xmlns:r="http://schemas.openxmlformats.org/officeDocument/2006/relationships" id="267" r:id="Rd772c8a4ae324911"/>
+    <p:sldId xmlns:r="http://schemas.openxmlformats.org/officeDocument/2006/relationships" id="256" r:id="R9fb7676cd19b491e"/>
+    <p:sldId xmlns:r="http://schemas.openxmlformats.org/officeDocument/2006/relationships" id="257" r:id="Rb674dfba38824a45"/>
+    <p:sldId xmlns:r="http://schemas.openxmlformats.org/officeDocument/2006/relationships" id="258" r:id="R138a8fff4d8046b8"/>
+    <p:sldId xmlns:r="http://schemas.openxmlformats.org/officeDocument/2006/relationships" id="259" r:id="Rd37547115de64ff9"/>
+    <p:sldId xmlns:r="http://schemas.openxmlformats.org/officeDocument/2006/relationships" id="260" r:id="R797fec7445324cea"/>
+    <p:sldId xmlns:r="http://schemas.openxmlformats.org/officeDocument/2006/relationships" id="261" r:id="Rfe7447142f064bf5"/>
+    <p:sldId xmlns:r="http://schemas.openxmlformats.org/officeDocument/2006/relationships" id="262" r:id="Rfbccddc59fa4482a"/>
+    <p:sldId xmlns:r="http://schemas.openxmlformats.org/officeDocument/2006/relationships" id="263" r:id="R5fc7614c98254080"/>
+    <p:sldId xmlns:r="http://schemas.openxmlformats.org/officeDocument/2006/relationships" id="264" r:id="Rf94b9883b6e045ad"/>
+    <p:sldId xmlns:r="http://schemas.openxmlformats.org/officeDocument/2006/relationships" id="265" r:id="Rc46fb48c015c44ed"/>
+    <p:sldId xmlns:r="http://schemas.openxmlformats.org/officeDocument/2006/relationships" id="266" r:id="R9f320f3477554c5a"/>
+    <p:sldId xmlns:r="http://schemas.openxmlformats.org/officeDocument/2006/relationships" id="267" r:id="R8528954ee9ad4656"/>
   </p:sldIdLst>
   <p:sldSz cx="12192000" cy="6858000"/>
   <p:notesSz cx="6858000" cy="9144000"/>
@@ -1291,7 +1291,7 @@
   </p:cSld>
   <p:clrMap bg1="lt1" tx1="dk1" bg2="lt2" tx2="dk2" accent1="accent1" accent2="accent2" accent3="accent3" accent4="accent4" accent5="accent5" accent6="accent6" hlink="hlink" folHlink="folHlink"/>
   <p:sldLayoutIdLst>
-    <p:sldLayoutId xmlns:r="http://schemas.openxmlformats.org/officeDocument/2006/relationships" id="2147483649" r:id="R6bb55af08d3a43df"/>
+    <p:sldLayoutId xmlns:r="http://schemas.openxmlformats.org/officeDocument/2006/relationships" id="2147483649" r:id="R4828b63d2f66451b"/>
   </p:sldLayoutIdLst>
   <p:txStyles>
     <p:titleStyle>
@@ -3614,7 +3614,7 @@
                   <a:srgbClr val="5B6472"/>
                 </a:solidFill>
               </a:rPr>
-              <a:t>Codex와 Claude Code가 같은 업무 맥락을 참고하도록 구성한 개인 개발 환경</a:t>
+              <a:t>분석부터 구현·테스트·기록까지 AI와 협업하고, 변경 범위와 반영 여부는 직접 결정</a:t>
             </a:r>
           </a:p>
         </p:txBody>
@@ -3921,7 +3921,7 @@
                 <a:ea typeface="Calibri"/>
                 <a:cs typeface="Calibri"/>
               </a:rPr>
-              <a:t>작업 규칙과 검증 기준</a:t>
+              <a:t>개발자가 변경 범위와</a:t>
             </a:r>
           </a:p>
           <a:p xmlns:a="http://schemas.openxmlformats.org/drawingml/2006/main">
@@ -3945,7 +3945,7 @@
                 <a:ea typeface="Calibri"/>
                 <a:cs typeface="Calibri"/>
               </a:rPr>
-              <a:t>AI가 참고할 범위와</a:t>
+              <a:t>완료 기준을 먼저 정하고</a:t>
             </a:r>
           </a:p>
           <a:p xmlns:a="http://schemas.openxmlformats.org/drawingml/2006/main">
@@ -3969,7 +3969,7 @@
                 <a:ea typeface="Calibri"/>
                 <a:cs typeface="Calibri"/>
               </a:rPr>
-              <a:t>확인 절차를 명시</a:t>
+              <a:t>작업 규칙과 확인 절차를 명시</a:t>
             </a:r>
           </a:p>
         </p:txBody>
@@ -4641,7 +4641,7 @@
                 <a:ea typeface="Calibri"/>
                 <a:cs typeface="Calibri"/>
               </a:rPr>
-              <a:t>2. AI 분석·제안</a:t>
+              <a:t>2. AI 구현·테스트</a:t>
             </a:r>
           </a:p>
         </p:txBody>
@@ -4699,7 +4699,7 @@
                 <a:ea typeface="Calibri"/>
                 <a:cs typeface="Calibri"/>
               </a:rPr>
-              <a:t>원인 후보와 수정안 도출</a:t>
+              <a:t>원인 분석과 코드 구현</a:t>
             </a:r>
           </a:p>
           <a:p xmlns:a="http://schemas.openxmlformats.org/drawingml/2006/main">
@@ -4723,7 +4723,7 @@
                 <a:ea typeface="Calibri"/>
                 <a:cs typeface="Calibri"/>
               </a:rPr>
-              <a:t>분석·문서화 지원</a:t>
+              <a:t>테스트 작성에 활용</a:t>
             </a:r>
           </a:p>
         </p:txBody>
@@ -4839,7 +4839,7 @@
                 <a:ea typeface="Calibri"/>
                 <a:cs typeface="Calibri"/>
               </a:rPr>
-              <a:t>코드·SQL·로그·테스트로 검증</a:t>
+              <a:t>코드·테스트와 실제 API·DB 확인</a:t>
             </a:r>
           </a:p>
           <a:p xmlns:a="http://schemas.openxmlformats.org/drawingml/2006/main">
@@ -4863,7 +4863,7 @@
                 <a:ea typeface="Calibri"/>
                 <a:cs typeface="Calibri"/>
               </a:rPr>
-              <a:t>수정·적용 여부 직접 결정</a:t>
+              <a:t>업무 규칙·예외 검토 후 반영</a:t>
             </a:r>
           </a:p>
         </p:txBody>
@@ -5061,7 +5061,7 @@
                 <a:ea typeface="Calibri"/>
                 <a:cs typeface="Calibri"/>
               </a:rPr>
-              <a:t>적용 사례: 제휴 연동의 규격·오류 분석과 검증 결과를 기록해 후속 업무에 재사용</a:t>
+              <a:t>적용 사례: 제휴 연동의 구현·테스트에 활용하고 검증 결과를 하네스에 반영해 재사용</a:t>
             </a:r>
           </a:p>
         </p:txBody>
@@ -7712,8 +7712,22 @@
                   <a:srgbClr val="121722"/>
                 </a:solidFill>
               </a:rPr>
-              <a:t>제휴사와 규격·접속 조건 조율부터
-API·배치 개발과 오픈 전 검증까지 담당</a:t>
+              <a:t>제휴사와 규격·접속 조건 조율부터</a:t>
+            </a:r>
+            <a:br>
+              <a:rPr sz="1425" b="0" i="0">
+                <a:solidFill>
+                  <a:srgbClr val="121722"/>
+                </a:solidFill>
+              </a:rPr>
+            </a:br>
+            <a:r>
+              <a:rPr sz="1425" b="0" i="0">
+                <a:solidFill>
+                  <a:srgbClr val="121722"/>
+                </a:solidFill>
+              </a:rPr>
+              <a:t>API·배치 개발과 오픈 전 검증까지 담당</a:t>
             </a:r>
           </a:p>
         </p:txBody>
@@ -7795,8 +7809,22 @@
                   <a:srgbClr val="121722"/>
                 </a:solidFill>
               </a:rPr>
-              <a:t>주문·포인트·신청 정책을 데이터 처리와
-사용자·관리자 기능으로 구현</a:t>
+              <a:t>주문·포인트·신청 정책을 데이터 처리와</a:t>
+            </a:r>
+            <a:br>
+              <a:rPr sz="1425" b="0" i="0">
+                <a:solidFill>
+                  <a:srgbClr val="121722"/>
+                </a:solidFill>
+              </a:rPr>
+            </a:br>
+            <a:r>
+              <a:rPr sz="1425" b="0" i="0">
+                <a:solidFill>
+                  <a:srgbClr val="121722"/>
+                </a:solidFill>
+              </a:rPr>
+              <a:t>사용자·관리자 기능으로 구현</a:t>
             </a:r>
           </a:p>
         </p:txBody>
@@ -7878,8 +7906,22 @@
                   <a:srgbClr val="121722"/>
                 </a:solidFill>
               </a:rPr>
-              <a:t>CTO와 2인 TF에서 사내 첫 Python
-AI API 설계·구현과 배포 검증 주도</a:t>
+              <a:t>CTO와 2인 TF에서 사내 첫 Python</a:t>
+            </a:r>
+            <a:br>
+              <a:rPr sz="1425" b="0" i="0">
+                <a:solidFill>
+                  <a:srgbClr val="121722"/>
+                </a:solidFill>
+              </a:rPr>
+            </a:br>
+            <a:r>
+              <a:rPr sz="1425" b="0" i="0">
+                <a:solidFill>
+                  <a:srgbClr val="121722"/>
+                </a:solidFill>
+              </a:rPr>
+              <a:t>AI API 설계·구현과 배포 검증 주도</a:t>
             </a:r>
           </a:p>
         </p:txBody>
@@ -8012,8 +8054,22 @@
                   <a:srgbClr val="FFFFFF"/>
                 </a:solidFill>
               </a:rPr>
-              <a:t>주문 트랜잭션
-경계 분리</a:t>
+              <a:t>주문 트랜잭션</a:t>
+            </a:r>
+            <a:br>
+              <a:rPr sz="1425" b="1" i="0">
+                <a:solidFill>
+                  <a:srgbClr val="FFFFFF"/>
+                </a:solidFill>
+              </a:rPr>
+            </a:br>
+            <a:r>
+              <a:rPr sz="1425" b="1" i="0">
+                <a:solidFill>
+                  <a:srgbClr val="FFFFFF"/>
+                </a:solidFill>
+              </a:rPr>
+              <a:t>경계 분리</a:t>
             </a:r>
           </a:p>
         </p:txBody>
@@ -8064,8 +8120,22 @@
                   <a:srgbClr val="FFFFFF"/>
                 </a:solidFill>
               </a:rPr>
-              <a:t>제휴 응답
-예외 격리</a:t>
+              <a:t>제휴 응답</a:t>
+            </a:r>
+            <a:br>
+              <a:rPr sz="1425" b="1" i="0">
+                <a:solidFill>
+                  <a:srgbClr val="FFFFFF"/>
+                </a:solidFill>
+              </a:rPr>
+            </a:br>
+            <a:r>
+              <a:rPr sz="1425" b="1" i="0">
+                <a:solidFill>
+                  <a:srgbClr val="FFFFFF"/>
+                </a:solidFill>
+              </a:rPr>
+              <a:t>예외 격리</a:t>
             </a:r>
           </a:p>
         </p:txBody>
@@ -8116,8 +8186,22 @@
                   <a:srgbClr val="FFFFFF"/>
                 </a:solidFill>
               </a:rPr>
-              <a:t>재원별 포인트
-통계 기준 반영</a:t>
+              <a:t>재원별 포인트</a:t>
+            </a:r>
+            <a:br>
+              <a:rPr sz="1425" b="1" i="0">
+                <a:solidFill>
+                  <a:srgbClr val="FFFFFF"/>
+                </a:solidFill>
+              </a:rPr>
+            </a:br>
+            <a:r>
+              <a:rPr sz="1425" b="1" i="0">
+                <a:solidFill>
+                  <a:srgbClr val="FFFFFF"/>
+                </a:solidFill>
+              </a:rPr>
+              <a:t>통계 기준 반영</a:t>
             </a:r>
           </a:p>
         </p:txBody>
@@ -8168,8 +8252,22 @@
                   <a:srgbClr val="FFFFFF"/>
                 </a:solidFill>
               </a:rPr>
-              <a:t>AI 응답
-JSON 검증</a:t>
+              <a:t>AI 응답</a:t>
+            </a:r>
+            <a:br>
+              <a:rPr sz="1425" b="1" i="0">
+                <a:solidFill>
+                  <a:srgbClr val="FFFFFF"/>
+                </a:solidFill>
+              </a:rPr>
+            </a:br>
+            <a:r>
+              <a:rPr sz="1425" b="1" i="0">
+                <a:solidFill>
+                  <a:srgbClr val="FFFFFF"/>
+                </a:solidFill>
+              </a:rPr>
+              <a:t>JSON 검증</a:t>
             </a:r>
           </a:p>
         </p:txBody>
@@ -10029,8 +10127,22 @@
                   <a:srgbClr val="5B6472"/>
                 </a:solidFill>
               </a:rPr>
-              <a:t>주문·상품·검색 연동
-2026년부터 전담</a:t>
+              <a:t>주문·상품·검색 연동</a:t>
+            </a:r>
+            <a:br>
+              <a:rPr sz="1125" b="0" i="0">
+                <a:solidFill>
+                  <a:srgbClr val="5B6472"/>
+                </a:solidFill>
+              </a:rPr>
+            </a:br>
+            <a:r>
+              <a:rPr sz="1125" b="0" i="0">
+                <a:solidFill>
+                  <a:srgbClr val="5B6472"/>
+                </a:solidFill>
+              </a:rPr>
+              <a:t>2026년부터 전담</a:t>
             </a:r>
           </a:p>
         </p:txBody>
@@ -12131,8 +12243,22 @@
                   <a:srgbClr val="121722"/>
                 </a:solidFill>
               </a:rPr>
-              <a:t>주문 수집 API·누락 보정 배치 개발, 신규 제휴 검색 API 연동
-비동기 작업 등록 순서 개선과 타임아웃·결과 취합 흐름 분석</a:t>
+              <a:t>주문 수집 API·누락 보정 배치 개발, 신규 제휴 검색 API 연동</a:t>
+            </a:r>
+            <a:br>
+              <a:rPr sz="1425" b="0" i="0">
+                <a:solidFill>
+                  <a:srgbClr val="121722"/>
+                </a:solidFill>
+              </a:rPr>
+            </a:br>
+            <a:r>
+              <a:rPr sz="1425" b="0" i="0">
+                <a:solidFill>
+                  <a:srgbClr val="121722"/>
+                </a:solidFill>
+              </a:rPr>
+              <a:t>비동기 작업 등록 순서 개선과 타임아웃·결과 취합 흐름 분석</a:t>
             </a:r>
           </a:p>
         </p:txBody>
@@ -13134,7 +13260,7 @@
                   <a:srgbClr val="121722"/>
                 </a:solidFill>
               </a:rPr>
-              <a:t>제휴사별 규격·예외 사례를 공통 검증 절차로 정리해 신규 온보딩에 재사용</a:t>
+              <a:t>검색 노출 오류를 채널 분류·데이터 생성까지 추적하고 관리자 설정으로 개선</a:t>
             </a:r>
           </a:p>
         </p:txBody>
@@ -13592,7 +13718,7 @@
                   <a:srgbClr val="121722"/>
                 </a:solidFill>
               </a:rPr>
-              <a:t>주문·검색 처리 안정성 개선</a:t>
+              <a:t>주문·검색과 제휴 연동 안정성 개선</a:t>
             </a:r>
           </a:p>
         </p:txBody>
@@ -13643,7 +13769,7 @@
                   <a:srgbClr val="5B6472"/>
                 </a:solidFill>
               </a:rPr>
-              <a:t>트랜잭션 경계 분리와 비동기·병렬 제휴 검색의 예외 처리 개선</a:t>
+              <a:t>트랜잭션 경계 분리, 응답 오류 격리와 제휴 접속 구조 개선</a:t>
             </a:r>
           </a:p>
         </p:txBody>
@@ -14100,7 +14226,7 @@
                   <a:srgbClr val="121722"/>
                 </a:solidFill>
               </a:rPr>
-              <a:t>주문·검색 오류의 영향 범위를 줄이고 원인 추적 기준을 정리</a:t>
+              <a:t>실패 영향 격리, 접속 정책 설정화와 연결 오류 해결</a:t>
             </a:r>
           </a:p>
         </p:txBody>
@@ -15115,7 +15241,7 @@
         <p:spPr>
           <a:xfrm xmlns:a="http://schemas.openxmlformats.org/drawingml/2006/main">
             <a:off x="3486150" y="4495800"/>
-            <a:ext cx="742950" cy="457200"/>
+            <a:ext cx="742950" cy="228600"/>
           </a:xfrm>
           <a:prstGeom xmlns:a="http://schemas.openxmlformats.org/drawingml/2006/main" prst="rect">
             <a:avLst/>
@@ -15151,15 +15277,49 @@
                 <a:ea typeface="Calibri"/>
                 <a:cs typeface="Calibri"/>
               </a:rPr>
-              <a:t>분석</a:t>
-            </a:r>
-          </a:p>
+              <a:t>적용</a:t>
+            </a:r>
+          </a:p>
+        </p:txBody>
+      </p:sp>
+      <p:sp>
+        <p:nvSpPr>
+          <p:cNvPr id="49" name="">
+            <a:extLst xmlns:a="http://schemas.openxmlformats.org/drawingml/2006/main">
+              <a:ext uri="{FF2B5EF4-FFF2-40B4-BE49-F238E27FC236}">
+                <a16:creationId xmlns:a16="http://schemas.microsoft.com/office/drawing/2014/main" id="{BB46B8C3-0C7A-40BA-B6BB-65A84B87A9CD}"/>
+              </a:ext>
+            </a:extLst>
+          </p:cNvPr>
+          <p:cNvSpPr>
+            <a:spLocks xmlns:a="http://schemas.openxmlformats.org/drawingml/2006/main" noGrp="1"/>
+          </p:cNvSpPr>
+          <p:nvPr/>
+        </p:nvSpPr>
+        <p:spPr>
+          <a:xfrm xmlns:a="http://schemas.openxmlformats.org/drawingml/2006/main">
+            <a:off x="4286250" y="4495800"/>
+            <a:ext cx="7239000" cy="228600"/>
+          </a:xfrm>
+          <a:prstGeom xmlns:a="http://schemas.openxmlformats.org/drawingml/2006/main" prst="rect">
+            <a:avLst/>
+          </a:prstGeom>
+          <a:noFill xmlns:a="http://schemas.openxmlformats.org/drawingml/2006/main"/>
+          <a:ln xmlns:a="http://schemas.openxmlformats.org/drawingml/2006/main" w="0">
+            <a:noFill/>
+          </a:ln>
+        </p:spPr>
+        <p:txBody>
+          <a:bodyPr xmlns:a="http://schemas.openxmlformats.org/drawingml/2006/main">
+            <a:noAutofit/>
+          </a:bodyPr>
+          <a:lstStyle xmlns:a="http://schemas.openxmlformats.org/drawingml/2006/main"/>
           <a:p xmlns:a="http://schemas.openxmlformats.org/drawingml/2006/main">
             <a:pPr>
               <a:buNone/>
-              <a:defRPr sz="1125" b="1">
-                <a:solidFill>
-                  <a:srgbClr val="4258FF"/>
+              <a:defRPr sz="1275" b="0">
+                <a:solidFill>
+                  <a:srgbClr val="596579"/>
                 </a:solidFill>
                 <a:latin typeface="Calibri"/>
                 <a:ea typeface="Calibri"/>
@@ -15167,37 +15327,37 @@
               </a:defRPr>
             </a:pPr>
             <a:r>
-              <a:rPr sz="1125" b="1">
-                <a:solidFill>
-                  <a:srgbClr val="4258FF"/>
+              <a:rPr sz="1275" b="0">
+                <a:solidFill>
+                  <a:srgbClr val="596579"/>
                 </a:solidFill>
                 <a:latin typeface="Calibri"/>
                 <a:ea typeface="Calibri"/>
                 <a:cs typeface="Calibri"/>
               </a:rPr>
-              <a:t>적용</a:t>
-            </a:r>
-          </a:p>
-        </p:txBody>
-      </p:sp>
-      <p:sp>
-        <p:nvSpPr>
-          <p:cNvPr id="49" name="">
-            <a:extLst xmlns:a="http://schemas.openxmlformats.org/drawingml/2006/main">
-              <a:ext uri="{FF2B5EF4-FFF2-40B4-BE49-F238E27FC236}">
-                <a16:creationId xmlns:a16="http://schemas.microsoft.com/office/drawing/2014/main" id="{BB46B8C3-0C7A-40BA-B6BB-65A84B87A9CD}"/>
-              </a:ext>
-            </a:extLst>
-          </p:cNvPr>
-          <p:cNvSpPr>
-            <a:spLocks xmlns:a="http://schemas.openxmlformats.org/drawingml/2006/main" noGrp="1"/>
-          </p:cNvSpPr>
-          <p:nvPr/>
-        </p:nvSpPr>
-        <p:spPr>
-          <a:xfrm xmlns:a="http://schemas.openxmlformats.org/drawingml/2006/main">
-            <a:off x="4286250" y="4495800"/>
-            <a:ext cx="7239000" cy="457200"/>
+              <a:t>호출 흐름과 타임아웃·결과 취합 방식을 분석해 신규 연동에 적용</a:t>
+            </a:r>
+          </a:p>
+        </p:txBody>
+      </p:sp>
+      <p:sp>
+        <p:nvSpPr>
+          <p:cNvPr id="50" name="">
+            <a:extLst xmlns:a="http://schemas.openxmlformats.org/drawingml/2006/main">
+              <a:ext uri="{FF2B5EF4-FFF2-40B4-BE49-F238E27FC236}">
+                <a16:creationId xmlns:a16="http://schemas.microsoft.com/office/drawing/2014/main" id="{BF740517-376D-4027-8029-DDCFF087E9AF}"/>
+              </a:ext>
+            </a:extLst>
+          </p:cNvPr>
+          <p:cNvSpPr>
+            <a:spLocks xmlns:a="http://schemas.openxmlformats.org/drawingml/2006/main" noGrp="1"/>
+          </p:cNvSpPr>
+          <p:nvPr/>
+        </p:nvSpPr>
+        <p:spPr>
+          <a:xfrm xmlns:a="http://schemas.openxmlformats.org/drawingml/2006/main">
+            <a:off x="3486150" y="4876800"/>
+            <a:ext cx="381000" cy="209550"/>
           </a:xfrm>
           <a:prstGeom xmlns:a="http://schemas.openxmlformats.org/drawingml/2006/main" prst="rect">
             <a:avLst/>
@@ -15215,9 +15375,9 @@
           <a:p xmlns:a="http://schemas.openxmlformats.org/drawingml/2006/main">
             <a:pPr>
               <a:buNone/>
-              <a:defRPr sz="1275" b="0">
-                <a:solidFill>
-                  <a:srgbClr val="596579"/>
+              <a:defRPr sz="900" b="1">
+                <a:solidFill>
+                  <a:srgbClr val="4258FF"/>
                 </a:solidFill>
                 <a:latin typeface="Calibri"/>
                 <a:ea typeface="Calibri"/>
@@ -15225,23 +15385,57 @@
               </a:defRPr>
             </a:pPr>
             <a:r>
-              <a:rPr sz="1275" b="0">
-                <a:solidFill>
-                  <a:srgbClr val="596579"/>
+              <a:rPr sz="900" b="1">
+                <a:solidFill>
+                  <a:srgbClr val="4258FF"/>
                 </a:solidFill>
                 <a:latin typeface="Calibri"/>
                 <a:ea typeface="Calibri"/>
                 <a:cs typeface="Calibri"/>
               </a:rPr>
-              <a:t>CompletableFuture·ThreadPoolTaskExecutor·WebClient 호출 흐름 분석</a:t>
-            </a:r>
-          </a:p>
+              <a:t>03</a:t>
+            </a:r>
+          </a:p>
+        </p:txBody>
+      </p:sp>
+      <p:sp>
+        <p:nvSpPr>
+          <p:cNvPr id="51" name="">
+            <a:extLst xmlns:a="http://schemas.openxmlformats.org/drawingml/2006/main">
+              <a:ext uri="{FF2B5EF4-FFF2-40B4-BE49-F238E27FC236}">
+                <a16:creationId xmlns:a16="http://schemas.microsoft.com/office/drawing/2014/main" id="{23B9888A-593D-4188-B207-A57F8629B29A}"/>
+              </a:ext>
+            </a:extLst>
+          </p:cNvPr>
+          <p:cNvSpPr>
+            <a:spLocks xmlns:a="http://schemas.openxmlformats.org/drawingml/2006/main" noGrp="1"/>
+          </p:cNvSpPr>
+          <p:nvPr/>
+        </p:nvSpPr>
+        <p:spPr>
+          <a:xfrm xmlns:a="http://schemas.openxmlformats.org/drawingml/2006/main">
+            <a:off x="3924300" y="4838700"/>
+            <a:ext cx="7524750" cy="304800"/>
+          </a:xfrm>
+          <a:prstGeom xmlns:a="http://schemas.openxmlformats.org/drawingml/2006/main" prst="rect">
+            <a:avLst/>
+          </a:prstGeom>
+          <a:noFill xmlns:a="http://schemas.openxmlformats.org/drawingml/2006/main"/>
+          <a:ln xmlns:a="http://schemas.openxmlformats.org/drawingml/2006/main" w="0">
+            <a:noFill/>
+          </a:ln>
+        </p:spPr>
+        <p:txBody>
+          <a:bodyPr xmlns:a="http://schemas.openxmlformats.org/drawingml/2006/main">
+            <a:noAutofit/>
+          </a:bodyPr>
+          <a:lstStyle xmlns:a="http://schemas.openxmlformats.org/drawingml/2006/main"/>
           <a:p xmlns:a="http://schemas.openxmlformats.org/drawingml/2006/main">
             <a:pPr>
               <a:buNone/>
-              <a:defRPr sz="1275" b="0">
-                <a:solidFill>
-                  <a:srgbClr val="596579"/>
+              <a:defRPr sz="1650" b="1">
+                <a:solidFill>
+                  <a:srgbClr val="141A26"/>
                 </a:solidFill>
                 <a:latin typeface="Calibri"/>
                 <a:ea typeface="Calibri"/>
@@ -15249,37 +15443,37 @@
               </a:defRPr>
             </a:pPr>
             <a:r>
-              <a:rPr sz="1275" b="0">
-                <a:solidFill>
-                  <a:srgbClr val="596579"/>
+              <a:rPr sz="1650" b="1">
+                <a:solidFill>
+                  <a:srgbClr val="141A26"/>
                 </a:solidFill>
                 <a:latin typeface="Calibri"/>
                 <a:ea typeface="Calibri"/>
                 <a:cs typeface="Calibri"/>
               </a:rPr>
-              <a:t>타임아웃·결과 취합 방식을 확인하고 신규 제휴 API 연동에 적용</a:t>
-            </a:r>
-          </a:p>
-        </p:txBody>
-      </p:sp>
-      <p:sp>
-        <p:nvSpPr>
-          <p:cNvPr id="50" name="">
-            <a:extLst xmlns:a="http://schemas.openxmlformats.org/drawingml/2006/main">
-              <a:ext uri="{FF2B5EF4-FFF2-40B4-BE49-F238E27FC236}">
-                <a16:creationId xmlns:a16="http://schemas.microsoft.com/office/drawing/2014/main" id="{BF740517-376D-4027-8029-DDCFF087E9AF}"/>
-              </a:ext>
-            </a:extLst>
-          </p:cNvPr>
-          <p:cNvSpPr>
-            <a:spLocks xmlns:a="http://schemas.openxmlformats.org/drawingml/2006/main" noGrp="1"/>
-          </p:cNvSpPr>
-          <p:nvPr/>
-        </p:nvSpPr>
-        <p:spPr>
-          <a:xfrm xmlns:a="http://schemas.openxmlformats.org/drawingml/2006/main">
-            <a:off x="3486150" y="5276850"/>
-            <a:ext cx="381000" cy="209550"/>
+              <a:t>Proxy 정책 설정화와 502 오류 해결</a:t>
+            </a:r>
+          </a:p>
+        </p:txBody>
+      </p:sp>
+      <p:sp>
+        <p:nvSpPr>
+          <p:cNvPr id="52" name="">
+            <a:extLst xmlns:a="http://schemas.openxmlformats.org/drawingml/2006/main">
+              <a:ext uri="{FF2B5EF4-FFF2-40B4-BE49-F238E27FC236}">
+                <a16:creationId xmlns:a16="http://schemas.microsoft.com/office/drawing/2014/main" id="{C31740F6-862C-4089-BAFC-252DC302FB64}"/>
+              </a:ext>
+            </a:extLst>
+          </p:cNvPr>
+          <p:cNvSpPr>
+            <a:spLocks xmlns:a="http://schemas.openxmlformats.org/drawingml/2006/main" noGrp="1"/>
+          </p:cNvSpPr>
+          <p:nvPr/>
+        </p:nvSpPr>
+        <p:spPr>
+          <a:xfrm xmlns:a="http://schemas.openxmlformats.org/drawingml/2006/main">
+            <a:off x="3486150" y="5219700"/>
+            <a:ext cx="742950" cy="381000"/>
           </a:xfrm>
           <a:prstGeom xmlns:a="http://schemas.openxmlformats.org/drawingml/2006/main" prst="rect">
             <a:avLst/>
@@ -15297,7 +15491,7 @@
           <a:p xmlns:a="http://schemas.openxmlformats.org/drawingml/2006/main">
             <a:pPr>
               <a:buNone/>
-              <a:defRPr sz="900" b="1">
+              <a:defRPr sz="1125" b="1">
                 <a:solidFill>
                   <a:srgbClr val="4258FF"/>
                 </a:solidFill>
@@ -15307,7 +15501,7 @@
               </a:defRPr>
             </a:pPr>
             <a:r>
-              <a:rPr sz="900" b="1">
+              <a:rPr sz="1125" b="1">
                 <a:solidFill>
                   <a:srgbClr val="4258FF"/>
                 </a:solidFill>
@@ -15315,29 +15509,29 @@
                 <a:ea typeface="Calibri"/>
                 <a:cs typeface="Calibri"/>
               </a:rPr>
-              <a:t>03</a:t>
-            </a:r>
-          </a:p>
-        </p:txBody>
-      </p:sp>
-      <p:sp>
-        <p:nvSpPr>
-          <p:cNvPr id="51" name="">
-            <a:extLst xmlns:a="http://schemas.openxmlformats.org/drawingml/2006/main">
-              <a:ext uri="{FF2B5EF4-FFF2-40B4-BE49-F238E27FC236}">
-                <a16:creationId xmlns:a16="http://schemas.microsoft.com/office/drawing/2014/main" id="{23B9888A-593D-4188-B207-A57F8629B29A}"/>
-              </a:ext>
-            </a:extLst>
-          </p:cNvPr>
-          <p:cNvSpPr>
-            <a:spLocks xmlns:a="http://schemas.openxmlformats.org/drawingml/2006/main" noGrp="1"/>
-          </p:cNvSpPr>
-          <p:nvPr/>
-        </p:nvSpPr>
-        <p:spPr>
-          <a:xfrm xmlns:a="http://schemas.openxmlformats.org/drawingml/2006/main">
-            <a:off x="3924300" y="5238750"/>
-            <a:ext cx="7524750" cy="304800"/>
+              <a:t>설정</a:t>
+            </a:r>
+          </a:p>
+        </p:txBody>
+      </p:sp>
+      <p:sp>
+        <p:nvSpPr>
+          <p:cNvPr id="53" name="">
+            <a:extLst xmlns:a="http://schemas.openxmlformats.org/drawingml/2006/main">
+              <a:ext uri="{FF2B5EF4-FFF2-40B4-BE49-F238E27FC236}">
+                <a16:creationId xmlns:a16="http://schemas.microsoft.com/office/drawing/2014/main" id="{26FB7A8F-3C15-4CF0-90C3-A1626631063D}"/>
+              </a:ext>
+            </a:extLst>
+          </p:cNvPr>
+          <p:cNvSpPr>
+            <a:spLocks xmlns:a="http://schemas.openxmlformats.org/drawingml/2006/main" noGrp="1"/>
+          </p:cNvSpPr>
+          <p:nvPr/>
+        </p:nvSpPr>
+        <p:spPr>
+          <a:xfrm xmlns:a="http://schemas.openxmlformats.org/drawingml/2006/main">
+            <a:off x="4286250" y="5219700"/>
+            <a:ext cx="7239000" cy="419100"/>
           </a:xfrm>
           <a:prstGeom xmlns:a="http://schemas.openxmlformats.org/drawingml/2006/main" prst="rect">
             <a:avLst/>
@@ -15355,9 +15549,9 @@
           <a:p xmlns:a="http://schemas.openxmlformats.org/drawingml/2006/main">
             <a:pPr>
               <a:buNone/>
-              <a:defRPr sz="1650" b="1">
-                <a:solidFill>
-                  <a:srgbClr val="141A26"/>
+              <a:defRPr sz="1275" b="0">
+                <a:solidFill>
+                  <a:srgbClr val="596579"/>
                 </a:solidFill>
                 <a:latin typeface="Calibri"/>
                 <a:ea typeface="Calibri"/>
@@ -15365,37 +15559,61 @@
               </a:defRPr>
             </a:pPr>
             <a:r>
-              <a:rPr sz="1650" b="1">
-                <a:solidFill>
-                  <a:srgbClr val="141A26"/>
+              <a:rPr sz="1275" b="0">
+                <a:solidFill>
+                  <a:srgbClr val="596579"/>
                 </a:solidFill>
                 <a:latin typeface="Calibri"/>
                 <a:ea typeface="Calibri"/>
                 <a:cs typeface="Calibri"/>
               </a:rPr>
-              <a:t>검색 결과의 원인 추적</a:t>
-            </a:r>
-          </a:p>
-        </p:txBody>
-      </p:sp>
-      <p:sp>
-        <p:nvSpPr>
-          <p:cNvPr id="52" name="">
-            <a:extLst xmlns:a="http://schemas.openxmlformats.org/drawingml/2006/main">
-              <a:ext uri="{FF2B5EF4-FFF2-40B4-BE49-F238E27FC236}">
-                <a16:creationId xmlns:a16="http://schemas.microsoft.com/office/drawing/2014/main" id="{C31740F6-862C-4089-BAFC-252DC302FB64}"/>
-              </a:ext>
-            </a:extLst>
-          </p:cNvPr>
-          <p:cNvSpPr>
-            <a:spLocks xmlns:a="http://schemas.openxmlformats.org/drawingml/2006/main" noGrp="1"/>
-          </p:cNvSpPr>
-          <p:nvPr/>
-        </p:nvSpPr>
-        <p:spPr>
-          <a:xfrm xmlns:a="http://schemas.openxmlformats.org/drawingml/2006/main">
-            <a:off x="3486150" y="5600700"/>
-            <a:ext cx="742950" cy="228600"/>
+              <a:t>제휴사별 Proxy 기준을 DB 설정·공통 정책으로 일원화해 운영 배포</a:t>
+            </a:r>
+          </a:p>
+          <a:p xmlns:a="http://schemas.openxmlformats.org/drawingml/2006/main">
+            <a:pPr>
+              <a:buNone/>
+              <a:defRPr sz="1275" b="0">
+                <a:solidFill>
+                  <a:srgbClr val="596579"/>
+                </a:solidFill>
+                <a:latin typeface="Calibri"/>
+                <a:ea typeface="Calibri"/>
+                <a:cs typeface="Calibri"/>
+              </a:defRPr>
+            </a:pPr>
+            <a:r>
+              <a:rPr sz="1275" b="0">
+                <a:solidFill>
+                  <a:srgbClr val="596579"/>
+                </a:solidFill>
+                <a:latin typeface="Calibri"/>
+                <a:ea typeface="Calibri"/>
+                <a:cs typeface="Calibri"/>
+              </a:rPr>
+              <a:t>대상 변경을 코드 배포 없이 설정으로 처리</a:t>
+            </a:r>
+          </a:p>
+        </p:txBody>
+      </p:sp>
+      <p:sp>
+        <p:nvSpPr>
+          <p:cNvPr id="54" name="">
+            <a:extLst xmlns:a="http://schemas.openxmlformats.org/drawingml/2006/main">
+              <a:ext uri="{FF2B5EF4-FFF2-40B4-BE49-F238E27FC236}">
+                <a16:creationId xmlns:a16="http://schemas.microsoft.com/office/drawing/2014/main" id="{C526EACA-FBFE-46F1-9547-9A701162E090}"/>
+              </a:ext>
+            </a:extLst>
+          </p:cNvPr>
+          <p:cNvSpPr>
+            <a:spLocks xmlns:a="http://schemas.openxmlformats.org/drawingml/2006/main" noGrp="1"/>
+          </p:cNvSpPr>
+          <p:nvPr/>
+        </p:nvSpPr>
+        <p:spPr>
+          <a:xfrm xmlns:a="http://schemas.openxmlformats.org/drawingml/2006/main">
+            <a:off x="3486150" y="5695950"/>
+            <a:ext cx="742950" cy="381000"/>
           </a:xfrm>
           <a:prstGeom xmlns:a="http://schemas.openxmlformats.org/drawingml/2006/main" prst="rect">
             <a:avLst/>
@@ -15431,29 +15649,29 @@
                 <a:ea typeface="Calibri"/>
                 <a:cs typeface="Calibri"/>
               </a:rPr>
-              <a:t>추적</a:t>
-            </a:r>
-          </a:p>
-        </p:txBody>
-      </p:sp>
-      <p:sp>
-        <p:nvSpPr>
-          <p:cNvPr id="53" name="">
-            <a:extLst xmlns:a="http://schemas.openxmlformats.org/drawingml/2006/main">
-              <a:ext uri="{FF2B5EF4-FFF2-40B4-BE49-F238E27FC236}">
-                <a16:creationId xmlns:a16="http://schemas.microsoft.com/office/drawing/2014/main" id="{26FB7A8F-3C15-4CF0-90C3-A1626631063D}"/>
-              </a:ext>
-            </a:extLst>
-          </p:cNvPr>
-          <p:cNvSpPr>
-            <a:spLocks xmlns:a="http://schemas.openxmlformats.org/drawingml/2006/main" noGrp="1"/>
-          </p:cNvSpPr>
-          <p:nvPr/>
-        </p:nvSpPr>
-        <p:spPr>
-          <a:xfrm xmlns:a="http://schemas.openxmlformats.org/drawingml/2006/main">
-            <a:off x="4286250" y="5600700"/>
-            <a:ext cx="7239000" cy="228600"/>
+              <a:t>오류</a:t>
+            </a:r>
+          </a:p>
+        </p:txBody>
+      </p:sp>
+      <p:sp>
+        <p:nvSpPr>
+          <p:cNvPr id="55" name="">
+            <a:extLst xmlns:a="http://schemas.openxmlformats.org/drawingml/2006/main">
+              <a:ext uri="{FF2B5EF4-FFF2-40B4-BE49-F238E27FC236}">
+                <a16:creationId xmlns:a16="http://schemas.microsoft.com/office/drawing/2014/main" id="{DFCFDFDF-7B2F-40B7-8094-198203BA35E5}"/>
+              </a:ext>
+            </a:extLst>
+          </p:cNvPr>
+          <p:cNvSpPr>
+            <a:spLocks xmlns:a="http://schemas.openxmlformats.org/drawingml/2006/main" noGrp="1"/>
+          </p:cNvSpPr>
+          <p:nvPr/>
+        </p:nvSpPr>
+        <p:spPr>
+          <a:xfrm xmlns:a="http://schemas.openxmlformats.org/drawingml/2006/main">
+            <a:off x="4286250" y="5695950"/>
+            <a:ext cx="7239000" cy="419100"/>
           </a:xfrm>
           <a:prstGeom xmlns:a="http://schemas.openxmlformats.org/drawingml/2006/main" prst="rect">
             <a:avLst/>
@@ -15489,49 +15707,15 @@
                 <a:ea typeface="Calibri"/>
                 <a:cs typeface="Calibri"/>
               </a:rPr>
-              <a:t>매핑이 정상인 상품의 후처리·검색 데이터 생성 과정을 추적</a:t>
-            </a:r>
-          </a:p>
-        </p:txBody>
-      </p:sp>
-      <p:sp>
-        <p:nvSpPr>
-          <p:cNvPr id="54" name="">
-            <a:extLst xmlns:a="http://schemas.openxmlformats.org/drawingml/2006/main">
-              <a:ext uri="{FF2B5EF4-FFF2-40B4-BE49-F238E27FC236}">
-                <a16:creationId xmlns:a16="http://schemas.microsoft.com/office/drawing/2014/main" id="{C526EACA-FBFE-46F1-9547-9A701162E090}"/>
-              </a:ext>
-            </a:extLst>
-          </p:cNvPr>
-          <p:cNvSpPr>
-            <a:spLocks xmlns:a="http://schemas.openxmlformats.org/drawingml/2006/main" noGrp="1"/>
-          </p:cNvSpPr>
-          <p:nvPr/>
-        </p:nvSpPr>
-        <p:spPr>
-          <a:xfrm xmlns:a="http://schemas.openxmlformats.org/drawingml/2006/main">
-            <a:off x="3486150" y="5829300"/>
-            <a:ext cx="742950" cy="228600"/>
-          </a:xfrm>
-          <a:prstGeom xmlns:a="http://schemas.openxmlformats.org/drawingml/2006/main" prst="rect">
-            <a:avLst/>
-          </a:prstGeom>
-          <a:noFill xmlns:a="http://schemas.openxmlformats.org/drawingml/2006/main"/>
-          <a:ln xmlns:a="http://schemas.openxmlformats.org/drawingml/2006/main" w="0">
-            <a:noFill/>
-          </a:ln>
-        </p:spPr>
-        <p:txBody>
-          <a:bodyPr xmlns:a="http://schemas.openxmlformats.org/drawingml/2006/main">
-            <a:noAutofit/>
-          </a:bodyPr>
-          <a:lstStyle xmlns:a="http://schemas.openxmlformats.org/drawingml/2006/main"/>
+              <a:t>개발 연동 환경의 끊어진 커넥션 재사용을 추적</a:t>
+            </a:r>
+          </a:p>
           <a:p xmlns:a="http://schemas.openxmlformats.org/drawingml/2006/main">
             <a:pPr>
               <a:buNone/>
-              <a:defRPr sz="1125" b="1">
-                <a:solidFill>
-                  <a:srgbClr val="4258FF"/>
+              <a:defRPr sz="1275" b="0">
+                <a:solidFill>
+                  <a:srgbClr val="596579"/>
                 </a:solidFill>
                 <a:latin typeface="Calibri"/>
                 <a:ea typeface="Calibri"/>
@@ -15539,73 +15723,15 @@
               </a:defRPr>
             </a:pPr>
             <a:r>
-              <a:rPr sz="1125" b="1">
-                <a:solidFill>
-                  <a:srgbClr val="4258FF"/>
+              <a:rPr sz="1275" b="0">
+                <a:solidFill>
+                  <a:srgbClr val="596579"/>
                 </a:solidFill>
                 <a:latin typeface="Calibri"/>
                 <a:ea typeface="Calibri"/>
                 <a:cs typeface="Calibri"/>
               </a:rPr>
-              <a:t>확인</a:t>
-            </a:r>
-          </a:p>
-        </p:txBody>
-      </p:sp>
-      <p:sp>
-        <p:nvSpPr>
-          <p:cNvPr id="55" name="">
-            <a:extLst xmlns:a="http://schemas.openxmlformats.org/drawingml/2006/main">
-              <a:ext uri="{FF2B5EF4-FFF2-40B4-BE49-F238E27FC236}">
-                <a16:creationId xmlns:a16="http://schemas.microsoft.com/office/drawing/2014/main" id="{DFCFDFDF-7B2F-40B7-8094-198203BA35E5}"/>
-              </a:ext>
-            </a:extLst>
-          </p:cNvPr>
-          <p:cNvSpPr>
-            <a:spLocks xmlns:a="http://schemas.openxmlformats.org/drawingml/2006/main" noGrp="1"/>
-          </p:cNvSpPr>
-          <p:nvPr/>
-        </p:nvSpPr>
-        <p:spPr>
-          <a:xfrm xmlns:a="http://schemas.openxmlformats.org/drawingml/2006/main">
-            <a:off x="4286250" y="5829300"/>
-            <a:ext cx="7239000" cy="228600"/>
-          </a:xfrm>
-          <a:prstGeom xmlns:a="http://schemas.openxmlformats.org/drawingml/2006/main" prst="rect">
-            <a:avLst/>
-          </a:prstGeom>
-          <a:noFill xmlns:a="http://schemas.openxmlformats.org/drawingml/2006/main"/>
-          <a:ln xmlns:a="http://schemas.openxmlformats.org/drawingml/2006/main" w="0">
-            <a:noFill/>
-          </a:ln>
-        </p:spPr>
-        <p:txBody>
-          <a:bodyPr xmlns:a="http://schemas.openxmlformats.org/drawingml/2006/main">
-            <a:noAutofit/>
-          </a:bodyPr>
-          <a:lstStyle xmlns:a="http://schemas.openxmlformats.org/drawingml/2006/main"/>
-          <a:p xmlns:a="http://schemas.openxmlformats.org/drawingml/2006/main">
-            <a:pPr>
-              <a:buNone/>
-              <a:defRPr sz="1275" b="0">
-                <a:solidFill>
-                  <a:srgbClr val="596579"/>
-                </a:solidFill>
-                <a:latin typeface="Calibri"/>
-                <a:ea typeface="Calibri"/>
-                <a:cs typeface="Calibri"/>
-              </a:defRPr>
-            </a:pPr>
-            <a:r>
-              <a:rPr sz="1275" b="0">
-                <a:solidFill>
-                  <a:srgbClr val="596579"/>
-                </a:solidFill>
-                <a:latin typeface="Calibri"/>
-                <a:ea typeface="Calibri"/>
-                <a:cs typeface="Calibri"/>
-              </a:rPr>
-              <a:t>추가 검색상품 생성 구간을 확인해 의도와 다른 노출의 원인을 분리</a:t>
+              <a:t>인프라팀과 Apache 커넥션 TTL을 조정해 간헐적 502 해결</a:t>
             </a:r>
           </a:p>
         </p:txBody>
@@ -15999,8 +16125,22 @@
                   <a:srgbClr val="121722"/>
                 </a:solidFill>
               </a:rPr>
-              <a:t>근로자·기업·정부 재원별 포인트를 구분해
-주문·사용내역과 통계 산출 기준에 반영</a:t>
+              <a:t>근로자·기업·정부 재원별 포인트를 구분해</a:t>
+            </a:r>
+            <a:br>
+              <a:rPr sz="1425" b="1" i="0">
+                <a:solidFill>
+                  <a:srgbClr val="121722"/>
+                </a:solidFill>
+              </a:rPr>
+            </a:br>
+            <a:r>
+              <a:rPr sz="1425" b="1" i="0">
+                <a:solidFill>
+                  <a:srgbClr val="121722"/>
+                </a:solidFill>
+              </a:rPr>
+              <a:t>주문·사용내역과 통계 산출 기준에 반영</a:t>
             </a:r>
           </a:p>
         </p:txBody>
@@ -16130,8 +16270,22 @@
                   <a:srgbClr val="121722"/>
                 </a:solidFill>
               </a:rPr>
-              <a:t>주문·포인트 원천 데이터를 일자·상품 유형·지역·포인트 그룹별로 재구성
-국회요구자료 조회·엑셀 출력과 일일 리포트 데이터 처리 구현</a:t>
+              <a:t>주문·포인트 원천 데이터를 일자·상품 유형·지역·포인트 그룹별로 재구성</a:t>
+            </a:r>
+            <a:br>
+              <a:rPr sz="1425" b="1" i="0">
+                <a:solidFill>
+                  <a:srgbClr val="121722"/>
+                </a:solidFill>
+              </a:rPr>
+            </a:br>
+            <a:r>
+              <a:rPr sz="1425" b="1" i="0">
+                <a:solidFill>
+                  <a:srgbClr val="121722"/>
+                </a:solidFill>
+              </a:rPr>
+              <a:t>국회요구자료 조회·엑셀 출력과 일일 리포트 데이터 처리 구현</a:t>
             </a:r>
           </a:p>
         </p:txBody>
@@ -16261,8 +16415,22 @@
                   <a:srgbClr val="121722"/>
                 </a:solidFill>
               </a:rPr>
-              <a:t>부적합 상품의 후보 확인·운영자 판정·노출 제외 기능 구현
-메시지 발송 대상 엑셀 업로드로 반복 대량 업무를 관리자 기능으로 전환</a:t>
+              <a:t>부적합 상품의 후보 확인·운영자 판정·노출 제외 기능 구현</a:t>
+            </a:r>
+            <a:br>
+              <a:rPr sz="1425" b="1" i="0">
+                <a:solidFill>
+                  <a:srgbClr val="121722"/>
+                </a:solidFill>
+              </a:rPr>
+            </a:br>
+            <a:r>
+              <a:rPr sz="1425" b="1" i="0">
+                <a:solidFill>
+                  <a:srgbClr val="121722"/>
+                </a:solidFill>
+              </a:rPr>
+              <a:t>메시지 발송 대상 엑셀 업로드로 반복 대량 업무를 관리자 기능으로 전환</a:t>
             </a:r>
           </a:p>
         </p:txBody>
@@ -16364,8 +16532,22 @@
                   <a:srgbClr val="121722"/>
                 </a:solidFill>
               </a:rPr>
-              <a:t>Redis 기반 Spring Session·Spring Cache의 세션·검색·외부 API 응답 캐시 흐름을 분석하고
-관련 기능 개발·운영</a:t>
+              <a:t>Redis 기반 Spring Session·Spring Cache의 세션·검색·외부 API 응답 캐시 흐름을 분석하고</a:t>
+            </a:r>
+            <a:br>
+              <a:rPr sz="1350" b="0" i="0">
+                <a:solidFill>
+                  <a:srgbClr val="121722"/>
+                </a:solidFill>
+              </a:rPr>
+            </a:br>
+            <a:r>
+              <a:rPr sz="1350" b="0" i="0">
+                <a:solidFill>
+                  <a:srgbClr val="121722"/>
+                </a:solidFill>
+              </a:rPr>
+              <a:t>관련 기능 개발·운영</a:t>
             </a:r>
           </a:p>
         </p:txBody>
@@ -17281,8 +17463,22 @@
                   <a:srgbClr val="121722"/>
                 </a:solidFill>
               </a:rPr>
-              <a:t>예약 기간·시간대 정원·중복 신청 제한을 반영하고
-개인정보 동의와 신청 이력까지 연결</a:t>
+              <a:t>예약 기간·시간대 정원·중복 신청 제한을 반영하고</a:t>
+            </a:r>
+            <a:br>
+              <a:rPr sz="1425" b="0" i="0">
+                <a:solidFill>
+                  <a:srgbClr val="121722"/>
+                </a:solidFill>
+              </a:rPr>
+            </a:br>
+            <a:r>
+              <a:rPr sz="1425" b="0" i="0">
+                <a:solidFill>
+                  <a:srgbClr val="121722"/>
+                </a:solidFill>
+              </a:rPr>
+              <a:t>개인정보 동의와 신청 이력까지 연결</a:t>
             </a:r>
           </a:p>
         </p:txBody>
@@ -17364,8 +17560,22 @@
                   <a:srgbClr val="121722"/>
                 </a:solidFill>
               </a:rPr>
-              <a:t>복지카드·신청·동의 기능에 현재값과 변경 이력을
-함께 관리하는 데이터 구조 적용</a:t>
+              <a:t>복지카드·신청·동의 기능에 현재값과 변경 이력을</a:t>
+            </a:r>
+            <a:br>
+              <a:rPr sz="1425" b="0" i="0">
+                <a:solidFill>
+                  <a:srgbClr val="121722"/>
+                </a:solidFill>
+              </a:rPr>
+            </a:br>
+            <a:r>
+              <a:rPr sz="1425" b="0" i="0">
+                <a:solidFill>
+                  <a:srgbClr val="121722"/>
+                </a:solidFill>
+              </a:rPr>
+              <a:t>함께 관리하는 데이터 구조 적용</a:t>
             </a:r>
           </a:p>
         </p:txBody>
@@ -17447,8 +17657,22 @@
                   <a:srgbClr val="121722"/>
                 </a:solidFill>
               </a:rPr>
-              <a:t>공공 복지 신청의 본문·첨부파일·처리 상태를
-사용자 화면과 관리자 조회 기능으로 구현</a:t>
+              <a:t>공공 복지 신청의 본문·첨부파일·처리 상태를</a:t>
+            </a:r>
+            <a:br>
+              <a:rPr sz="1425" b="0" i="0">
+                <a:solidFill>
+                  <a:srgbClr val="121722"/>
+                </a:solidFill>
+              </a:rPr>
+            </a:br>
+            <a:r>
+              <a:rPr sz="1425" b="0" i="0">
+                <a:solidFill>
+                  <a:srgbClr val="121722"/>
+                </a:solidFill>
+              </a:rPr>
+              <a:t>사용자 화면과 관리자 조회 기능으로 구현</a:t>
             </a:r>
           </a:p>
         </p:txBody>
@@ -17550,8 +17774,22 @@
                   <a:srgbClr val="121722"/>
                 </a:solidFill>
               </a:rPr>
-              <a:t>관리자 조회의 민감정보 마스킹과 인증·세션·접근제어,
-XSS/CSRF 점검 항목을 개선하고 기존 업무 흐름 유지</a:t>
+              <a:t>관리자 조회의 민감정보 마스킹과 인증·세션·접근제어,</a:t>
+            </a:r>
+            <a:br>
+              <a:rPr sz="1425" b="0" i="0">
+                <a:solidFill>
+                  <a:srgbClr val="121722"/>
+                </a:solidFill>
+              </a:rPr>
+            </a:br>
+            <a:r>
+              <a:rPr sz="1425" b="0" i="0">
+                <a:solidFill>
+                  <a:srgbClr val="121722"/>
+                </a:solidFill>
+              </a:rPr>
+              <a:t>XSS/CSRF 점검 항목을 개선하고 기존 업무 흐름 유지</a:t>
             </a:r>
           </a:p>
         </p:txBody>
@@ -18223,8 +18461,22 @@
                   <a:srgbClr val="121722"/>
                 </a:solidFill>
               </a:rPr>
-              <a:t>JSON 파싱·검증·보정과 응답 상태 설계로
-모델 출력을 서비스 API 계약에 연결</a:t>
+              <a:t>JSON 파싱·검증·보정과 응답 상태 설계로</a:t>
+            </a:r>
+            <a:br>
+              <a:rPr sz="1275" b="0" i="0">
+                <a:solidFill>
+                  <a:srgbClr val="121722"/>
+                </a:solidFill>
+              </a:rPr>
+            </a:br>
+            <a:r>
+              <a:rPr sz="1275" b="0" i="0">
+                <a:solidFill>
+                  <a:srgbClr val="121722"/>
+                </a:solidFill>
+              </a:rPr>
+              <a:t>모델 출력을 서비스 API 계약에 연결</a:t>
             </a:r>
           </a:p>
         </p:txBody>
@@ -18306,8 +18558,22 @@
                   <a:srgbClr val="121722"/>
                 </a:solidFill>
               </a:rPr>
-              <a:t>Oracle에 이력을 보존하고 프로세스 내 LRU 캐시로
-세션별 최근 대화 맥락 관리</a:t>
+              <a:t>Oracle에 이력을 보존하고 프로세스 내 LRU 캐시로</a:t>
+            </a:r>
+            <a:br>
+              <a:rPr sz="1275" b="0" i="0">
+                <a:solidFill>
+                  <a:srgbClr val="121722"/>
+                </a:solidFill>
+              </a:rPr>
+            </a:br>
+            <a:r>
+              <a:rPr sz="1275" b="0" i="0">
+                <a:solidFill>
+                  <a:srgbClr val="121722"/>
+                </a:solidFill>
+              </a:rPr>
+              <a:t>세션별 최근 대화 맥락 관리</a:t>
             </a:r>
           </a:p>
         </p:txBody>
@@ -18389,8 +18655,22 @@
                   <a:srgbClr val="121722"/>
                 </a:solidFill>
               </a:rPr>
-              <a:t>독립 Docker API 서버와 GitLab CI·Nomad 배포 구성,
-인프라팀과 DB·Proxy·로그·상태 점검·롤백 검증</a:t>
+              <a:t>독립 Docker API 서버와 GitLab CI·Nomad 배포 구성,</a:t>
+            </a:r>
+            <a:br>
+              <a:rPr sz="1275" b="0" i="0">
+                <a:solidFill>
+                  <a:srgbClr val="121722"/>
+                </a:solidFill>
+              </a:rPr>
+            </a:br>
+            <a:r>
+              <a:rPr sz="1275" b="0" i="0">
+                <a:solidFill>
+                  <a:srgbClr val="121722"/>
+                </a:solidFill>
+              </a:rPr>
+              <a:t>인프라팀과 DB·Proxy·로그·상태 점검·롤백 검증</a:t>
             </a:r>
           </a:p>
         </p:txBody>
@@ -18581,14 +18861,20 @@
       </p:sp>
       <p:pic>
         <p:nvPicPr>
-          <p:cNvPr id="47" name=""/>
+          <p:cNvPr id="47" name="">
+            <a:extLst xmlns:a="http://schemas.openxmlformats.org/drawingml/2006/main">
+              <a:ext uri="{FF2B5EF4-FFF2-40B4-BE49-F238E27FC236}">
+                <a16:creationId xmlns:a16="http://schemas.microsoft.com/office/drawing/2014/main" id="{08A99509-BC06-4D14-A0C0-0FF0B9573C51}"/>
+              </a:ext>
+            </a:extLst>
+          </p:cNvPr>
           <p:cNvPicPr>
             <a:picLocks xmlns:a="http://schemas.openxmlformats.org/drawingml/2006/main" noChangeAspect="1"/>
           </p:cNvPicPr>
           <p:nvPr/>
         </p:nvPicPr>
         <p:blipFill>
-          <a:blip xmlns:r="http://schemas.openxmlformats.org/officeDocument/2006/relationships" xmlns:a="http://schemas.openxmlformats.org/drawingml/2006/main" r:embed="R28d2c070fec84a40"/>
+          <a:blip xmlns:r="http://schemas.openxmlformats.org/officeDocument/2006/relationships" xmlns:a="http://schemas.openxmlformats.org/drawingml/2006/main" r:embed="Rbf97df3161284e8c"/>
           <a:stretch xmlns:a="http://schemas.openxmlformats.org/drawingml/2006/main"/>
         </p:blipFill>
         <p:spPr>
@@ -18605,14 +18891,20 @@
       </p:pic>
       <p:pic>
         <p:nvPicPr>
-          <p:cNvPr id="48" name=""/>
+          <p:cNvPr id="48" name="">
+            <a:extLst xmlns:a="http://schemas.openxmlformats.org/drawingml/2006/main">
+              <a:ext uri="{FF2B5EF4-FFF2-40B4-BE49-F238E27FC236}">
+                <a16:creationId xmlns:a16="http://schemas.microsoft.com/office/drawing/2014/main" id="{7EBAD545-0980-4B4B-BFB8-E06C83AA6EE7}"/>
+              </a:ext>
+            </a:extLst>
+          </p:cNvPr>
           <p:cNvPicPr>
             <a:picLocks xmlns:a="http://schemas.openxmlformats.org/drawingml/2006/main" noChangeAspect="1"/>
           </p:cNvPicPr>
           <p:nvPr/>
         </p:nvPicPr>
         <p:blipFill>
-          <a:blip xmlns:r="http://schemas.openxmlformats.org/officeDocument/2006/relationships" xmlns:a="http://schemas.openxmlformats.org/drawingml/2006/main" r:embed="Rd4f45f70c9e444e3"/>
+          <a:blip xmlns:r="http://schemas.openxmlformats.org/officeDocument/2006/relationships" xmlns:a="http://schemas.openxmlformats.org/drawingml/2006/main" r:embed="R88ed0ca364ac47cb"/>
           <a:stretch xmlns:a="http://schemas.openxmlformats.org/drawingml/2006/main"/>
         </p:blipFill>
         <p:spPr>
@@ -18629,14 +18921,20 @@
       </p:pic>
       <p:pic>
         <p:nvPicPr>
-          <p:cNvPr id="49" name=""/>
+          <p:cNvPr id="49" name="">
+            <a:extLst xmlns:a="http://schemas.openxmlformats.org/drawingml/2006/main">
+              <a:ext uri="{FF2B5EF4-FFF2-40B4-BE49-F238E27FC236}">
+                <a16:creationId xmlns:a16="http://schemas.microsoft.com/office/drawing/2014/main" id="{F05F375F-FA41-4E03-8C23-A50280869AC0}"/>
+              </a:ext>
+            </a:extLst>
+          </p:cNvPr>
           <p:cNvPicPr>
             <a:picLocks xmlns:a="http://schemas.openxmlformats.org/drawingml/2006/main" noChangeAspect="1"/>
           </p:cNvPicPr>
           <p:nvPr/>
         </p:nvPicPr>
         <p:blipFill>
-          <a:blip xmlns:r="http://schemas.openxmlformats.org/officeDocument/2006/relationships" xmlns:a="http://schemas.openxmlformats.org/drawingml/2006/main" r:embed="R92929f019d324f44"/>
+          <a:blip xmlns:r="http://schemas.openxmlformats.org/officeDocument/2006/relationships" xmlns:a="http://schemas.openxmlformats.org/drawingml/2006/main" r:embed="Rb4a265ccd63845a9"/>
           <a:stretch xmlns:a="http://schemas.openxmlformats.org/drawingml/2006/main"/>
         </p:blipFill>
         <p:spPr>

</xml_diff>

<commit_message>
docs: add Duo Flex to portfolio PPT and PDFs
</commit_message>
<xml_diff>
--- a/public/downloads/heetae-lee-portfolio.pptx
+++ b/public/downloads/heetae-lee-portfolio.pptx
@@ -2,24 +2,25 @@
 <file path=ppt/presentation.xml><?xml version="1.0" encoding="utf-8"?>
 <p:presentation xmlns:p="http://schemas.openxmlformats.org/presentationml/2006/main">
   <p:sldMasterIdLst>
-    <p:sldMasterId xmlns:r="http://schemas.openxmlformats.org/officeDocument/2006/relationships" id="2147483648" r:id="R3563b7c7620046a9"/>
+    <p:sldMasterId xmlns:r="http://schemas.openxmlformats.org/officeDocument/2006/relationships" id="2147483648" r:id="R37a55583194b4be7"/>
   </p:sldMasterIdLst>
   <p:notesMasterIdLst>
-    <p:notesMasterId xmlns:r="http://schemas.openxmlformats.org/officeDocument/2006/relationships" r:id="Rc78c8d66333e41bb"/>
+    <p:notesMasterId xmlns:r="http://schemas.openxmlformats.org/officeDocument/2006/relationships" r:id="R3ef362cd6a804dd8"/>
   </p:notesMasterIdLst>
   <p:sldIdLst>
-    <p:sldId xmlns:r="http://schemas.openxmlformats.org/officeDocument/2006/relationships" id="256" r:id="R9fb7676cd19b491e"/>
-    <p:sldId xmlns:r="http://schemas.openxmlformats.org/officeDocument/2006/relationships" id="257" r:id="Rb674dfba38824a45"/>
-    <p:sldId xmlns:r="http://schemas.openxmlformats.org/officeDocument/2006/relationships" id="258" r:id="R138a8fff4d8046b8"/>
-    <p:sldId xmlns:r="http://schemas.openxmlformats.org/officeDocument/2006/relationships" id="259" r:id="Rd37547115de64ff9"/>
-    <p:sldId xmlns:r="http://schemas.openxmlformats.org/officeDocument/2006/relationships" id="260" r:id="R797fec7445324cea"/>
-    <p:sldId xmlns:r="http://schemas.openxmlformats.org/officeDocument/2006/relationships" id="261" r:id="Rfe7447142f064bf5"/>
-    <p:sldId xmlns:r="http://schemas.openxmlformats.org/officeDocument/2006/relationships" id="262" r:id="Rfbccddc59fa4482a"/>
-    <p:sldId xmlns:r="http://schemas.openxmlformats.org/officeDocument/2006/relationships" id="263" r:id="R5fc7614c98254080"/>
-    <p:sldId xmlns:r="http://schemas.openxmlformats.org/officeDocument/2006/relationships" id="264" r:id="Rf94b9883b6e045ad"/>
-    <p:sldId xmlns:r="http://schemas.openxmlformats.org/officeDocument/2006/relationships" id="265" r:id="Rc46fb48c015c44ed"/>
-    <p:sldId xmlns:r="http://schemas.openxmlformats.org/officeDocument/2006/relationships" id="266" r:id="R9f320f3477554c5a"/>
-    <p:sldId xmlns:r="http://schemas.openxmlformats.org/officeDocument/2006/relationships" id="267" r:id="R8528954ee9ad4656"/>
+    <p:sldId xmlns:r="http://schemas.openxmlformats.org/officeDocument/2006/relationships" id="256" r:id="Ra98a791228b74e85"/>
+    <p:sldId xmlns:r="http://schemas.openxmlformats.org/officeDocument/2006/relationships" id="257" r:id="R8b7cf2057602415f"/>
+    <p:sldId xmlns:r="http://schemas.openxmlformats.org/officeDocument/2006/relationships" id="258" r:id="R0130b8f30de8405d"/>
+    <p:sldId xmlns:r="http://schemas.openxmlformats.org/officeDocument/2006/relationships" id="259" r:id="R5346d82e81a8429e"/>
+    <p:sldId xmlns:r="http://schemas.openxmlformats.org/officeDocument/2006/relationships" id="260" r:id="R39967d3a4e814655"/>
+    <p:sldId xmlns:r="http://schemas.openxmlformats.org/officeDocument/2006/relationships" id="261" r:id="R1d38f2ec2f0e49fd"/>
+    <p:sldId xmlns:r="http://schemas.openxmlformats.org/officeDocument/2006/relationships" id="262" r:id="Rea1cc4ca87684ec3"/>
+    <p:sldId xmlns:r="http://schemas.openxmlformats.org/officeDocument/2006/relationships" id="263" r:id="Rc5409196a344494c"/>
+    <p:sldId xmlns:r="http://schemas.openxmlformats.org/officeDocument/2006/relationships" id="264" r:id="R28c744aac59c494c"/>
+    <p:sldId xmlns:r="http://schemas.openxmlformats.org/officeDocument/2006/relationships" id="265" r:id="R24c23d8cafc949ac"/>
+    <p:sldId xmlns:r="http://schemas.openxmlformats.org/officeDocument/2006/relationships" id="266" r:id="R9ad851d998f04dee"/>
+    <p:sldId xmlns:r="http://schemas.openxmlformats.org/officeDocument/2006/relationships" id="267" r:id="R8b1b0b4873084ea8"/>
+    <p:sldId xmlns:r="http://schemas.openxmlformats.org/officeDocument/2006/relationships" id="268" r:id="Rf39f889c009f449c"/>
   </p:sldIdLst>
   <p:sldSz cx="12192000" cy="6858000"/>
   <p:notesSz cx="6858000" cy="9144000"/>
@@ -661,6 +662,72 @@
         <p:txBody>
           <a:bodyPr xmlns:a="http://schemas.openxmlformats.org/drawingml/2006/main"/>
           <a:lstStyle xmlns:a="http://schemas.openxmlformats.org/drawingml/2006/main"/>
+          <a:p xmlns:a="http://schemas.openxmlformats.org/drawingml/2006/main"/>
+        </p:txBody>
+      </p:sp>
+      <p:sp>
+        <p:nvSpPr>
+          <p:cNvPr id="4" name="Slide Number Placeholder 3"/>
+          <p:cNvSpPr>
+            <a:spLocks xmlns:a="http://schemas.openxmlformats.org/drawingml/2006/main" noGrp="1"/>
+          </p:cNvSpPr>
+          <p:nvPr>
+            <p:ph type="sldNum" idx="5"/>
+          </p:nvPr>
+        </p:nvSpPr>
+        <p:spPr/>
+        <p:txBody>
+          <a:bodyPr xmlns:a="http://schemas.openxmlformats.org/drawingml/2006/main"/>
+          <a:lstStyle xmlns:a="http://schemas.openxmlformats.org/drawingml/2006/main"/>
+          <a:p xmlns:a="http://schemas.openxmlformats.org/drawingml/2006/main"/>
+        </p:txBody>
+      </p:sp>
+    </p:spTree>
+  </p:cSld>
+  <p:clrMapOvr>
+    <a:masterClrMapping xmlns:a="http://schemas.openxmlformats.org/drawingml/2006/main"/>
+  </p:clrMapOvr>
+</p:notes>
+</file>
+
+<file path=ppt/notesSlides/notesSlide13.xml><?xml version="1.0" encoding="utf-8"?>
+<p:notes xmlns:p="http://schemas.openxmlformats.org/presentationml/2006/main">
+  <p:cSld>
+    <p:spTree>
+      <p:nvGrpSpPr>
+        <p:cNvPr id="1" name=""/>
+        <p:cNvGrpSpPr/>
+        <p:nvPr/>
+      </p:nvGrpSpPr>
+      <p:grpSpPr>
+        <a:xfrm xmlns:a="http://schemas.openxmlformats.org/drawingml/2006/main"/>
+      </p:grpSpPr>
+      <p:sp>
+        <p:nvSpPr>
+          <p:cNvPr id="2" name="Slide Image Placeholder 1"/>
+          <p:cNvSpPr>
+            <a:spLocks xmlns:a="http://schemas.openxmlformats.org/drawingml/2006/main" noGrp="1"/>
+          </p:cNvSpPr>
+          <p:nvPr>
+            <p:ph type="sldImg" idx="0"/>
+          </p:nvPr>
+        </p:nvSpPr>
+        <p:spPr/>
+      </p:sp>
+      <p:sp>
+        <p:nvSpPr>
+          <p:cNvPr id="3" name="Notes Placeholder 2"/>
+          <p:cNvSpPr>
+            <a:spLocks xmlns:a="http://schemas.openxmlformats.org/drawingml/2006/main" noGrp="1"/>
+          </p:cNvSpPr>
+          <p:nvPr>
+            <p:ph type="body" idx="1"/>
+          </p:nvPr>
+        </p:nvSpPr>
+        <p:spPr/>
+        <p:txBody>
+          <a:bodyPr xmlns:a="http://schemas.openxmlformats.org/drawingml/2006/main"/>
+          <a:lstStyle xmlns:a="http://schemas.openxmlformats.org/drawingml/2006/main"/>
           <a:p xmlns:a="http://schemas.openxmlformats.org/drawingml/2006/main">
             <a:r>
               <a:t/>
@@ -1291,7 +1358,7 @@
   </p:cSld>
   <p:clrMap bg1="lt1" tx1="dk1" bg2="lt2" tx2="dk2" accent1="accent1" accent2="accent2" accent3="accent3" accent4="accent4" accent5="accent5" accent6="accent6" hlink="hlink" folHlink="folHlink"/>
   <p:sldLayoutIdLst>
-    <p:sldLayoutId xmlns:r="http://schemas.openxmlformats.org/officeDocument/2006/relationships" id="2147483649" r:id="R4828b63d2f66451b"/>
+    <p:sldLayoutId xmlns:r="http://schemas.openxmlformats.org/officeDocument/2006/relationships" id="2147483649" r:id="Rba65790041b14c51"/>
   </p:sldLayoutIdLst>
   <p:txStyles>
     <p:titleStyle>
@@ -2987,7 +3054,7 @@
                   <a:srgbClr val="FFFFFF"/>
                 </a:solidFill>
               </a:rPr>
-              <a:t>핵심 기여 요약</a:t>
+              <a:t>기여 요약 · 개인 프로젝트</a:t>
             </a:r>
           </a:p>
         </p:txBody>
@@ -3038,7 +3105,7 @@
                   <a:srgbClr val="AEB6C5"/>
                 </a:solidFill>
               </a:rPr>
-              <a:t>프로젝트별 책임과 구현 결과</a:t>
+              <a:t>회사 경력 요약과 개인 앱 출시</a:t>
             </a:r>
           </a:p>
         </p:txBody>
@@ -3350,7 +3417,7 @@
                 <a:ea typeface="Calibri"/>
                 <a:cs typeface="Calibri"/>
               </a:rPr>
-              <a:t>p. 11</a:t>
+              <a:t>pp. 11-12</a:t>
             </a:r>
           </a:p>
         </p:txBody>
@@ -6466,6 +6533,1924 @@
 </file>
 
 <file path=ppt/slides/slide12.xml><?xml version="1.0" encoding="utf-8"?>
+<p:sld xmlns:a="http://schemas.openxmlformats.org/drawingml/2006/main" xmlns:ns2="http://schemas.microsoft.com/office/drawing/2014/main" xmlns:ns4="http://schemas.microsoft.com/office/powerpoint/2010/main" xmlns:p="http://schemas.openxmlformats.org/presentationml/2006/main" xmlns:r="http://schemas.openxmlformats.org/officeDocument/2006/relationships">
+  <p:cSld>
+    <p:bg>
+      <p:bgPr>
+        <a:solidFill>
+          <a:srgbClr val="F5F6F8"/>
+        </a:solidFill>
+      </p:bgPr>
+    </p:bg>
+    <p:spTree>
+      <p:nvGrpSpPr>
+        <p:cNvPr id="1" name=""/>
+        <p:cNvGrpSpPr/>
+        <p:nvPr/>
+      </p:nvGrpSpPr>
+      <p:grpSpPr>
+        <a:xfrm/>
+      </p:grpSpPr>
+      <p:sp>
+        <p:nvSpPr>
+          <p:cNvPr id="17" name="page">
+            <a:extLst>
+              <a:ext uri="{FF2B5EF4-FFF2-40B4-BE49-F238E27FC236}">
+                <ns2:creationId id="{6FF93D06-30B0-4D39-92C4-0CD5314D9A69}"/>
+              </a:ext>
+            </a:extLst>
+          </p:cNvPr>
+          <p:cNvSpPr>
+            <a:spLocks noGrp="1"/>
+          </p:cNvSpPr>
+          <p:nvPr/>
+        </p:nvSpPr>
+        <p:spPr>
+          <a:xfrm>
+            <a:off x="647700" y="400050"/>
+            <a:ext cx="476250" cy="266700"/>
+          </a:xfrm>
+          <a:prstGeom prst="rect">
+            <a:avLst/>
+          </a:prstGeom>
+          <a:noFill/>
+          <a:ln w="0">
+            <a:noFill/>
+          </a:ln>
+        </p:spPr>
+        <p:txBody>
+          <a:bodyPr/>
+          <a:lstStyle>
+            <a:defPPr>
+              <a:defRPr sz="900" b="1">
+                <a:solidFill>
+                  <a:srgbClr val="354DFF"/>
+                </a:solidFill>
+              </a:defRPr>
+            </a:defPPr>
+            <a:lvl1pPr>
+              <a:buNone/>
+              <a:defRPr sz="900" b="1">
+                <a:solidFill>
+                  <a:srgbClr val="354DFF"/>
+                </a:solidFill>
+              </a:defRPr>
+            </a:lvl1pPr>
+            <a:lvl2pPr>
+              <a:buNone/>
+              <a:defRPr sz="900" b="1">
+                <a:solidFill>
+                  <a:srgbClr val="354DFF"/>
+                </a:solidFill>
+              </a:defRPr>
+            </a:lvl2pPr>
+            <a:lvl3pPr>
+              <a:buNone/>
+              <a:defRPr sz="900" b="1">
+                <a:solidFill>
+                  <a:srgbClr val="354DFF"/>
+                </a:solidFill>
+              </a:defRPr>
+            </a:lvl3pPr>
+            <a:lvl4pPr>
+              <a:buNone/>
+              <a:defRPr sz="900" b="1">
+                <a:solidFill>
+                  <a:srgbClr val="354DFF"/>
+                </a:solidFill>
+              </a:defRPr>
+            </a:lvl4pPr>
+            <a:lvl5pPr>
+              <a:buNone/>
+              <a:defRPr sz="900" b="1">
+                <a:solidFill>
+                  <a:srgbClr val="354DFF"/>
+                </a:solidFill>
+              </a:defRPr>
+            </a:lvl5pPr>
+            <a:lvl6pPr>
+              <a:buNone/>
+              <a:defRPr sz="900" b="1">
+                <a:solidFill>
+                  <a:srgbClr val="354DFF"/>
+                </a:solidFill>
+              </a:defRPr>
+            </a:lvl6pPr>
+            <a:lvl7pPr>
+              <a:buNone/>
+              <a:defRPr sz="900" b="1">
+                <a:solidFill>
+                  <a:srgbClr val="354DFF"/>
+                </a:solidFill>
+              </a:defRPr>
+            </a:lvl7pPr>
+            <a:lvl8pPr>
+              <a:buNone/>
+              <a:defRPr sz="900" b="1">
+                <a:solidFill>
+                  <a:srgbClr val="354DFF"/>
+                </a:solidFill>
+              </a:defRPr>
+            </a:lvl8pPr>
+            <a:lvl9pPr>
+              <a:buNone/>
+              <a:defRPr sz="900" b="1">
+                <a:solidFill>
+                  <a:srgbClr val="354DFF"/>
+                </a:solidFill>
+              </a:defRPr>
+            </a:lvl9pPr>
+          </a:lstStyle>
+          <a:p>
+            <a:pPr>
+              <a:buNone/>
+              <a:defRPr sz="900" b="1">
+                <a:solidFill>
+                  <a:srgbClr val="354DFF"/>
+                </a:solidFill>
+              </a:defRPr>
+            </a:pPr>
+            <a:r>
+              <a:rPr sz="900" b="1">
+                <a:solidFill>
+                  <a:srgbClr val="354DFF"/>
+                </a:solidFill>
+              </a:rPr>
+              <a:t>12</a:t>
+            </a:r>
+          </a:p>
+        </p:txBody>
+      </p:sp>
+      <p:sp>
+        <p:nvSpPr>
+          <p:cNvPr id="2" name="accent">
+            <a:extLst>
+              <a:ext uri="{FF2B5EF4-FFF2-40B4-BE49-F238E27FC236}">
+                <ns2:creationId id="{18CFE59B-7246-497E-9D2B-A231F24E3A57}"/>
+              </a:ext>
+            </a:extLst>
+          </p:cNvPr>
+          <p:cNvSpPr>
+            <a:spLocks noGrp="1"/>
+          </p:cNvSpPr>
+          <p:nvPr/>
+        </p:nvSpPr>
+        <p:spPr>
+          <a:xfrm>
+            <a:off x="1123950" y="514350"/>
+            <a:ext cx="419100" cy="9525"/>
+          </a:xfrm>
+          <a:prstGeom prst="rect">
+            <a:avLst/>
+          </a:prstGeom>
+          <a:solidFill>
+            <a:srgbClr val="354DFF"/>
+          </a:solidFill>
+          <a:ln w="0">
+            <a:noFill/>
+          </a:ln>
+        </p:spPr>
+      </p:sp>
+      <p:sp>
+        <p:nvSpPr>
+          <p:cNvPr id="3" name="eyebrow">
+            <a:extLst>
+              <a:ext uri="{FF2B5EF4-FFF2-40B4-BE49-F238E27FC236}">
+                <ns2:creationId id="{5E3C13C6-DC2B-4A43-AA2D-5C5811532301}"/>
+              </a:ext>
+            </a:extLst>
+          </p:cNvPr>
+          <p:cNvSpPr>
+            <a:spLocks noGrp="1"/>
+          </p:cNvSpPr>
+          <p:nvPr/>
+        </p:nvSpPr>
+        <p:spPr>
+          <a:xfrm>
+            <a:off x="1752600" y="457200"/>
+            <a:ext cx="3333750" cy="209550"/>
+          </a:xfrm>
+          <a:prstGeom prst="rect">
+            <a:avLst/>
+          </a:prstGeom>
+          <a:noFill/>
+          <a:ln w="0">
+            <a:noFill/>
+          </a:ln>
+        </p:spPr>
+        <p:txBody>
+          <a:bodyPr/>
+          <a:lstStyle>
+            <a:defPPr>
+              <a:defRPr sz="900" b="1">
+                <a:solidFill>
+                  <a:srgbClr val="5A6475"/>
+                </a:solidFill>
+              </a:defRPr>
+            </a:defPPr>
+            <a:lvl1pPr>
+              <a:buNone/>
+              <a:defRPr sz="900" b="1">
+                <a:solidFill>
+                  <a:srgbClr val="5A6475"/>
+                </a:solidFill>
+              </a:defRPr>
+            </a:lvl1pPr>
+            <a:lvl2pPr>
+              <a:buNone/>
+              <a:defRPr sz="900" b="1">
+                <a:solidFill>
+                  <a:srgbClr val="5A6475"/>
+                </a:solidFill>
+              </a:defRPr>
+            </a:lvl2pPr>
+            <a:lvl3pPr>
+              <a:buNone/>
+              <a:defRPr sz="900" b="1">
+                <a:solidFill>
+                  <a:srgbClr val="5A6475"/>
+                </a:solidFill>
+              </a:defRPr>
+            </a:lvl3pPr>
+            <a:lvl4pPr>
+              <a:buNone/>
+              <a:defRPr sz="900" b="1">
+                <a:solidFill>
+                  <a:srgbClr val="5A6475"/>
+                </a:solidFill>
+              </a:defRPr>
+            </a:lvl4pPr>
+            <a:lvl5pPr>
+              <a:buNone/>
+              <a:defRPr sz="900" b="1">
+                <a:solidFill>
+                  <a:srgbClr val="5A6475"/>
+                </a:solidFill>
+              </a:defRPr>
+            </a:lvl5pPr>
+            <a:lvl6pPr>
+              <a:buNone/>
+              <a:defRPr sz="900" b="1">
+                <a:solidFill>
+                  <a:srgbClr val="5A6475"/>
+                </a:solidFill>
+              </a:defRPr>
+            </a:lvl6pPr>
+            <a:lvl7pPr>
+              <a:buNone/>
+              <a:defRPr sz="900" b="1">
+                <a:solidFill>
+                  <a:srgbClr val="5A6475"/>
+                </a:solidFill>
+              </a:defRPr>
+            </a:lvl7pPr>
+            <a:lvl8pPr>
+              <a:buNone/>
+              <a:defRPr sz="900" b="1">
+                <a:solidFill>
+                  <a:srgbClr val="5A6475"/>
+                </a:solidFill>
+              </a:defRPr>
+            </a:lvl8pPr>
+            <a:lvl9pPr>
+              <a:buNone/>
+              <a:defRPr sz="900" b="1">
+                <a:solidFill>
+                  <a:srgbClr val="5A6475"/>
+                </a:solidFill>
+              </a:defRPr>
+            </a:lvl9pPr>
+          </a:lstStyle>
+          <a:p>
+            <a:pPr>
+              <a:buNone/>
+              <a:defRPr sz="900" b="1">
+                <a:solidFill>
+                  <a:srgbClr val="5A6475"/>
+                </a:solidFill>
+              </a:defRPr>
+            </a:pPr>
+            <a:r>
+              <a:rPr sz="900" b="1">
+                <a:solidFill>
+                  <a:srgbClr val="5A6475"/>
+                </a:solidFill>
+              </a:rPr>
+              <a:t>PERSONAL PROJECT</a:t>
+            </a:r>
+          </a:p>
+        </p:txBody>
+      </p:sp>
+      <p:sp>
+        <p:nvSpPr>
+          <p:cNvPr id="4" name="title">
+            <a:extLst>
+              <a:ext uri="{FF2B5EF4-FFF2-40B4-BE49-F238E27FC236}">
+                <ns2:creationId id="{3F934B5A-E42A-4AA2-8114-1D995E06F374}"/>
+              </a:ext>
+            </a:extLst>
+          </p:cNvPr>
+          <p:cNvSpPr>
+            <a:spLocks noGrp="1"/>
+          </p:cNvSpPr>
+          <p:nvPr/>
+        </p:nvSpPr>
+        <p:spPr>
+          <a:xfrm>
+            <a:off x="742950" y="838200"/>
+            <a:ext cx="10477500" cy="571500"/>
+          </a:xfrm>
+          <a:prstGeom prst="rect">
+            <a:avLst/>
+          </a:prstGeom>
+          <a:noFill/>
+          <a:ln w="0">
+            <a:noFill/>
+          </a:ln>
+        </p:spPr>
+        <p:txBody>
+          <a:bodyPr/>
+          <a:lstStyle>
+            <a:defPPr>
+              <a:defRPr sz="2850" b="1">
+                <a:solidFill>
+                  <a:srgbClr val="151A25"/>
+                </a:solidFill>
+              </a:defRPr>
+            </a:defPPr>
+            <a:lvl1pPr>
+              <a:buNone/>
+              <a:defRPr sz="2850" b="1">
+                <a:solidFill>
+                  <a:srgbClr val="151A25"/>
+                </a:solidFill>
+              </a:defRPr>
+            </a:lvl1pPr>
+            <a:lvl2pPr>
+              <a:buNone/>
+              <a:defRPr sz="2850" b="1">
+                <a:solidFill>
+                  <a:srgbClr val="151A25"/>
+                </a:solidFill>
+              </a:defRPr>
+            </a:lvl2pPr>
+            <a:lvl3pPr>
+              <a:buNone/>
+              <a:defRPr sz="2850" b="1">
+                <a:solidFill>
+                  <a:srgbClr val="151A25"/>
+                </a:solidFill>
+              </a:defRPr>
+            </a:lvl3pPr>
+            <a:lvl4pPr>
+              <a:buNone/>
+              <a:defRPr sz="2850" b="1">
+                <a:solidFill>
+                  <a:srgbClr val="151A25"/>
+                </a:solidFill>
+              </a:defRPr>
+            </a:lvl4pPr>
+            <a:lvl5pPr>
+              <a:buNone/>
+              <a:defRPr sz="2850" b="1">
+                <a:solidFill>
+                  <a:srgbClr val="151A25"/>
+                </a:solidFill>
+              </a:defRPr>
+            </a:lvl5pPr>
+            <a:lvl6pPr>
+              <a:buNone/>
+              <a:defRPr sz="2850" b="1">
+                <a:solidFill>
+                  <a:srgbClr val="151A25"/>
+                </a:solidFill>
+              </a:defRPr>
+            </a:lvl6pPr>
+            <a:lvl7pPr>
+              <a:buNone/>
+              <a:defRPr sz="2850" b="1">
+                <a:solidFill>
+                  <a:srgbClr val="151A25"/>
+                </a:solidFill>
+              </a:defRPr>
+            </a:lvl7pPr>
+            <a:lvl8pPr>
+              <a:buNone/>
+              <a:defRPr sz="2850" b="1">
+                <a:solidFill>
+                  <a:srgbClr val="151A25"/>
+                </a:solidFill>
+              </a:defRPr>
+            </a:lvl8pPr>
+            <a:lvl9pPr>
+              <a:buNone/>
+              <a:defRPr sz="2850" b="1">
+                <a:solidFill>
+                  <a:srgbClr val="151A25"/>
+                </a:solidFill>
+              </a:defRPr>
+            </a:lvl9pPr>
+          </a:lstStyle>
+          <a:p>
+            <a:pPr>
+              <a:buNone/>
+              <a:defRPr sz="2850" b="1">
+                <a:solidFill>
+                  <a:srgbClr val="151A25"/>
+                </a:solidFill>
+              </a:defRPr>
+            </a:pPr>
+            <a:r>
+              <a:rPr sz="2850" b="1">
+                <a:solidFill>
+                  <a:srgbClr val="151A25"/>
+                </a:solidFill>
+              </a:rPr>
+              <a:t>Duo Flex — 아이디어를 앱 출시까지</a:t>
+            </a:r>
+          </a:p>
+        </p:txBody>
+      </p:sp>
+      <p:sp>
+        <p:nvSpPr>
+          <p:cNvPr id="5" name="subtitle">
+            <a:extLst>
+              <a:ext uri="{FF2B5EF4-FFF2-40B4-BE49-F238E27FC236}">
+                <ns2:creationId id="{FE8C7F60-1800-4E9F-81DE-A1839397B227}"/>
+              </a:ext>
+            </a:extLst>
+          </p:cNvPr>
+          <p:cNvSpPr>
+            <a:spLocks noGrp="1"/>
+          </p:cNvSpPr>
+          <p:nvPr/>
+        </p:nvSpPr>
+        <p:spPr>
+          <a:xfrm>
+            <a:off x="742950" y="1485900"/>
+            <a:ext cx="10001250" cy="333375"/>
+          </a:xfrm>
+          <a:prstGeom prst="rect">
+            <a:avLst/>
+          </a:prstGeom>
+          <a:noFill/>
+          <a:ln w="0">
+            <a:noFill/>
+          </a:ln>
+        </p:spPr>
+        <p:txBody>
+          <a:bodyPr/>
+          <a:lstStyle>
+            <a:defPPr>
+              <a:defRPr sz="1575" b="0">
+                <a:solidFill>
+                  <a:srgbClr val="596579"/>
+                </a:solidFill>
+              </a:defRPr>
+            </a:defPPr>
+            <a:lvl1pPr>
+              <a:buNone/>
+              <a:defRPr sz="1575" b="0">
+                <a:solidFill>
+                  <a:srgbClr val="596579"/>
+                </a:solidFill>
+              </a:defRPr>
+            </a:lvl1pPr>
+            <a:lvl2pPr>
+              <a:buNone/>
+              <a:defRPr sz="1575" b="0">
+                <a:solidFill>
+                  <a:srgbClr val="596579"/>
+                </a:solidFill>
+              </a:defRPr>
+            </a:lvl2pPr>
+            <a:lvl3pPr>
+              <a:buNone/>
+              <a:defRPr sz="1575" b="0">
+                <a:solidFill>
+                  <a:srgbClr val="596579"/>
+                </a:solidFill>
+              </a:defRPr>
+            </a:lvl3pPr>
+            <a:lvl4pPr>
+              <a:buNone/>
+              <a:defRPr sz="1575" b="0">
+                <a:solidFill>
+                  <a:srgbClr val="596579"/>
+                </a:solidFill>
+              </a:defRPr>
+            </a:lvl4pPr>
+            <a:lvl5pPr>
+              <a:buNone/>
+              <a:defRPr sz="1575" b="0">
+                <a:solidFill>
+                  <a:srgbClr val="596579"/>
+                </a:solidFill>
+              </a:defRPr>
+            </a:lvl5pPr>
+            <a:lvl6pPr>
+              <a:buNone/>
+              <a:defRPr sz="1575" b="0">
+                <a:solidFill>
+                  <a:srgbClr val="596579"/>
+                </a:solidFill>
+              </a:defRPr>
+            </a:lvl6pPr>
+            <a:lvl7pPr>
+              <a:buNone/>
+              <a:defRPr sz="1575" b="0">
+                <a:solidFill>
+                  <a:srgbClr val="596579"/>
+                </a:solidFill>
+              </a:defRPr>
+            </a:lvl7pPr>
+            <a:lvl8pPr>
+              <a:buNone/>
+              <a:defRPr sz="1575" b="0">
+                <a:solidFill>
+                  <a:srgbClr val="596579"/>
+                </a:solidFill>
+              </a:defRPr>
+            </a:lvl8pPr>
+            <a:lvl9pPr>
+              <a:buNone/>
+              <a:defRPr sz="1575" b="0">
+                <a:solidFill>
+                  <a:srgbClr val="596579"/>
+                </a:solidFill>
+              </a:defRPr>
+            </a:lvl9pPr>
+          </a:lstStyle>
+          <a:p>
+            <a:pPr>
+              <a:buNone/>
+              <a:defRPr sz="1575" b="0">
+                <a:solidFill>
+                  <a:srgbClr val="596579"/>
+                </a:solidFill>
+              </a:defRPr>
+            </a:pPr>
+            <a:r>
+              <a:rPr sz="1575" b="0">
+                <a:solidFill>
+                  <a:srgbClr val="596579"/>
+                </a:solidFill>
+              </a:rPr>
+              <a:t>폴더블 화면 효과 앱  ·  Android / Java  ·  Google Play 출시</a:t>
+            </a:r>
+          </a:p>
+        </p:txBody>
+      </p:sp>
+      <p:sp>
+        <p:nvSpPr>
+          <p:cNvPr id="6" name="product-label">
+            <a:extLst>
+              <a:ext uri="{FF2B5EF4-FFF2-40B4-BE49-F238E27FC236}">
+                <ns2:creationId id="{D2D04BD3-7F8F-442E-B407-E0FA191612F9}"/>
+              </a:ext>
+            </a:extLst>
+          </p:cNvPr>
+          <p:cNvSpPr>
+            <a:spLocks noGrp="1"/>
+          </p:cNvSpPr>
+          <p:nvPr/>
+        </p:nvSpPr>
+        <p:spPr>
+          <a:xfrm>
+            <a:off x="742950" y="2105025"/>
+            <a:ext cx="6667500" cy="228600"/>
+          </a:xfrm>
+          <a:prstGeom prst="rect">
+            <a:avLst/>
+          </a:prstGeom>
+          <a:noFill/>
+          <a:ln w="0">
+            <a:noFill/>
+          </a:ln>
+        </p:spPr>
+        <p:txBody>
+          <a:bodyPr/>
+          <a:lstStyle>
+            <a:defPPr>
+              <a:defRPr sz="900" b="1">
+                <a:solidFill>
+                  <a:srgbClr val="354DFF"/>
+                </a:solidFill>
+              </a:defRPr>
+            </a:defPPr>
+            <a:lvl1pPr>
+              <a:buNone/>
+              <a:defRPr sz="900" b="1">
+                <a:solidFill>
+                  <a:srgbClr val="354DFF"/>
+                </a:solidFill>
+              </a:defRPr>
+            </a:lvl1pPr>
+            <a:lvl2pPr>
+              <a:buNone/>
+              <a:defRPr sz="900" b="1">
+                <a:solidFill>
+                  <a:srgbClr val="354DFF"/>
+                </a:solidFill>
+              </a:defRPr>
+            </a:lvl2pPr>
+            <a:lvl3pPr>
+              <a:buNone/>
+              <a:defRPr sz="900" b="1">
+                <a:solidFill>
+                  <a:srgbClr val="354DFF"/>
+                </a:solidFill>
+              </a:defRPr>
+            </a:lvl3pPr>
+            <a:lvl4pPr>
+              <a:buNone/>
+              <a:defRPr sz="900" b="1">
+                <a:solidFill>
+                  <a:srgbClr val="354DFF"/>
+                </a:solidFill>
+              </a:defRPr>
+            </a:lvl4pPr>
+            <a:lvl5pPr>
+              <a:buNone/>
+              <a:defRPr sz="900" b="1">
+                <a:solidFill>
+                  <a:srgbClr val="354DFF"/>
+                </a:solidFill>
+              </a:defRPr>
+            </a:lvl5pPr>
+            <a:lvl6pPr>
+              <a:buNone/>
+              <a:defRPr sz="900" b="1">
+                <a:solidFill>
+                  <a:srgbClr val="354DFF"/>
+                </a:solidFill>
+              </a:defRPr>
+            </a:lvl6pPr>
+            <a:lvl7pPr>
+              <a:buNone/>
+              <a:defRPr sz="900" b="1">
+                <a:solidFill>
+                  <a:srgbClr val="354DFF"/>
+                </a:solidFill>
+              </a:defRPr>
+            </a:lvl7pPr>
+            <a:lvl8pPr>
+              <a:buNone/>
+              <a:defRPr sz="900" b="1">
+                <a:solidFill>
+                  <a:srgbClr val="354DFF"/>
+                </a:solidFill>
+              </a:defRPr>
+            </a:lvl8pPr>
+            <a:lvl9pPr>
+              <a:buNone/>
+              <a:defRPr sz="900" b="1">
+                <a:solidFill>
+                  <a:srgbClr val="354DFF"/>
+                </a:solidFill>
+              </a:defRPr>
+            </a:lvl9pPr>
+          </a:lstStyle>
+          <a:p>
+            <a:pPr>
+              <a:buNone/>
+              <a:defRPr sz="900" b="1">
+                <a:solidFill>
+                  <a:srgbClr val="354DFF"/>
+                </a:solidFill>
+              </a:defRPr>
+            </a:pPr>
+            <a:r>
+              <a:rPr sz="900" b="1">
+                <a:solidFill>
+                  <a:srgbClr val="354DFF"/>
+                </a:solidFill>
+              </a:rPr>
+              <a:t>PRODUCT</a:t>
+            </a:r>
+          </a:p>
+        </p:txBody>
+      </p:sp>
+      <p:sp>
+        <p:nvSpPr>
+          <p:cNvPr id="7" name="product">
+            <a:extLst>
+              <a:ext uri="{FF2B5EF4-FFF2-40B4-BE49-F238E27FC236}">
+                <ns2:creationId id="{A799DB49-2C1B-4A41-B887-9E8978B49E62}"/>
+              </a:ext>
+            </a:extLst>
+          </p:cNvPr>
+          <p:cNvSpPr>
+            <a:spLocks noGrp="1"/>
+          </p:cNvSpPr>
+          <p:nvPr/>
+        </p:nvSpPr>
+        <p:spPr>
+          <a:xfrm>
+            <a:off x="742950" y="2400300"/>
+            <a:ext cx="7143750" cy="428625"/>
+          </a:xfrm>
+          <a:prstGeom prst="rect">
+            <a:avLst/>
+          </a:prstGeom>
+          <a:noFill/>
+          <a:ln w="0">
+            <a:noFill/>
+          </a:ln>
+        </p:spPr>
+        <p:txBody>
+          <a:bodyPr/>
+          <a:lstStyle>
+            <a:defPPr>
+              <a:defRPr sz="1875" b="1">
+                <a:solidFill>
+                  <a:srgbClr val="151A25"/>
+                </a:solidFill>
+              </a:defRPr>
+            </a:defPPr>
+            <a:lvl1pPr>
+              <a:buNone/>
+              <a:defRPr sz="1875" b="1">
+                <a:solidFill>
+                  <a:srgbClr val="151A25"/>
+                </a:solidFill>
+              </a:defRPr>
+            </a:lvl1pPr>
+            <a:lvl2pPr>
+              <a:buNone/>
+              <a:defRPr sz="1875" b="1">
+                <a:solidFill>
+                  <a:srgbClr val="151A25"/>
+                </a:solidFill>
+              </a:defRPr>
+            </a:lvl2pPr>
+            <a:lvl3pPr>
+              <a:buNone/>
+              <a:defRPr sz="1875" b="1">
+                <a:solidFill>
+                  <a:srgbClr val="151A25"/>
+                </a:solidFill>
+              </a:defRPr>
+            </a:lvl3pPr>
+            <a:lvl4pPr>
+              <a:buNone/>
+              <a:defRPr sz="1875" b="1">
+                <a:solidFill>
+                  <a:srgbClr val="151A25"/>
+                </a:solidFill>
+              </a:defRPr>
+            </a:lvl4pPr>
+            <a:lvl5pPr>
+              <a:buNone/>
+              <a:defRPr sz="1875" b="1">
+                <a:solidFill>
+                  <a:srgbClr val="151A25"/>
+                </a:solidFill>
+              </a:defRPr>
+            </a:lvl5pPr>
+            <a:lvl6pPr>
+              <a:buNone/>
+              <a:defRPr sz="1875" b="1">
+                <a:solidFill>
+                  <a:srgbClr val="151A25"/>
+                </a:solidFill>
+              </a:defRPr>
+            </a:lvl6pPr>
+            <a:lvl7pPr>
+              <a:buNone/>
+              <a:defRPr sz="1875" b="1">
+                <a:solidFill>
+                  <a:srgbClr val="151A25"/>
+                </a:solidFill>
+              </a:defRPr>
+            </a:lvl7pPr>
+            <a:lvl8pPr>
+              <a:buNone/>
+              <a:defRPr sz="1875" b="1">
+                <a:solidFill>
+                  <a:srgbClr val="151A25"/>
+                </a:solidFill>
+              </a:defRPr>
+            </a:lvl8pPr>
+            <a:lvl9pPr>
+              <a:buNone/>
+              <a:defRPr sz="1875" b="1">
+                <a:solidFill>
+                  <a:srgbClr val="151A25"/>
+                </a:solidFill>
+              </a:defRPr>
+            </a:lvl9pPr>
+          </a:lstStyle>
+          <a:p>
+            <a:pPr>
+              <a:buNone/>
+              <a:defRPr sz="1875" b="1">
+                <a:solidFill>
+                  <a:srgbClr val="151A25"/>
+                </a:solidFill>
+              </a:defRPr>
+            </a:pPr>
+            <a:r>
+              <a:rPr sz="1875" b="1">
+                <a:solidFill>
+                  <a:srgbClr val="151A25"/>
+                </a:solidFill>
+              </a:rPr>
+              <a:t>접힘 동작에 맞춰 깊이감과 블러 등의 화면 효과 제공</a:t>
+            </a:r>
+          </a:p>
+        </p:txBody>
+      </p:sp>
+      <p:sp>
+        <p:nvSpPr>
+          <p:cNvPr id="8" name="role-label">
+            <a:extLst>
+              <a:ext uri="{FF2B5EF4-FFF2-40B4-BE49-F238E27FC236}">
+                <ns2:creationId id="{C5C6BA4F-512E-4A9B-8FD1-B21F43345292}"/>
+              </a:ext>
+            </a:extLst>
+          </p:cNvPr>
+          <p:cNvSpPr>
+            <a:spLocks noGrp="1"/>
+          </p:cNvSpPr>
+          <p:nvPr/>
+        </p:nvSpPr>
+        <p:spPr>
+          <a:xfrm>
+            <a:off x="742950" y="3038475"/>
+            <a:ext cx="6667500" cy="304800"/>
+          </a:xfrm>
+          <a:prstGeom prst="rect">
+            <a:avLst/>
+          </a:prstGeom>
+          <a:noFill/>
+          <a:ln w="0">
+            <a:noFill/>
+          </a:ln>
+        </p:spPr>
+        <p:txBody>
+          <a:bodyPr/>
+          <a:lstStyle>
+            <a:defPPr>
+              <a:defRPr sz="1725" b="1">
+                <a:solidFill>
+                  <a:srgbClr val="151A25"/>
+                </a:solidFill>
+              </a:defRPr>
+            </a:defPPr>
+            <a:lvl1pPr>
+              <a:buNone/>
+              <a:defRPr sz="1725" b="1">
+                <a:solidFill>
+                  <a:srgbClr val="151A25"/>
+                </a:solidFill>
+              </a:defRPr>
+            </a:lvl1pPr>
+            <a:lvl2pPr>
+              <a:buNone/>
+              <a:defRPr sz="1725" b="1">
+                <a:solidFill>
+                  <a:srgbClr val="151A25"/>
+                </a:solidFill>
+              </a:defRPr>
+            </a:lvl2pPr>
+            <a:lvl3pPr>
+              <a:buNone/>
+              <a:defRPr sz="1725" b="1">
+                <a:solidFill>
+                  <a:srgbClr val="151A25"/>
+                </a:solidFill>
+              </a:defRPr>
+            </a:lvl3pPr>
+            <a:lvl4pPr>
+              <a:buNone/>
+              <a:defRPr sz="1725" b="1">
+                <a:solidFill>
+                  <a:srgbClr val="151A25"/>
+                </a:solidFill>
+              </a:defRPr>
+            </a:lvl4pPr>
+            <a:lvl5pPr>
+              <a:buNone/>
+              <a:defRPr sz="1725" b="1">
+                <a:solidFill>
+                  <a:srgbClr val="151A25"/>
+                </a:solidFill>
+              </a:defRPr>
+            </a:lvl5pPr>
+            <a:lvl6pPr>
+              <a:buNone/>
+              <a:defRPr sz="1725" b="1">
+                <a:solidFill>
+                  <a:srgbClr val="151A25"/>
+                </a:solidFill>
+              </a:defRPr>
+            </a:lvl6pPr>
+            <a:lvl7pPr>
+              <a:buNone/>
+              <a:defRPr sz="1725" b="1">
+                <a:solidFill>
+                  <a:srgbClr val="151A25"/>
+                </a:solidFill>
+              </a:defRPr>
+            </a:lvl7pPr>
+            <a:lvl8pPr>
+              <a:buNone/>
+              <a:defRPr sz="1725" b="1">
+                <a:solidFill>
+                  <a:srgbClr val="151A25"/>
+                </a:solidFill>
+              </a:defRPr>
+            </a:lvl8pPr>
+            <a:lvl9pPr>
+              <a:buNone/>
+              <a:defRPr sz="1725" b="1">
+                <a:solidFill>
+                  <a:srgbClr val="151A25"/>
+                </a:solidFill>
+              </a:defRPr>
+            </a:lvl9pPr>
+          </a:lstStyle>
+          <a:p>
+            <a:pPr>
+              <a:buNone/>
+              <a:defRPr sz="1725" b="1">
+                <a:solidFill>
+                  <a:srgbClr val="151A25"/>
+                </a:solidFill>
+              </a:defRPr>
+            </a:pPr>
+            <a:r>
+              <a:rPr sz="1725" b="1">
+                <a:solidFill>
+                  <a:srgbClr val="151A25"/>
+                </a:solidFill>
+              </a:rPr>
+              <a:t>내가 맡은 일</a:t>
+            </a:r>
+          </a:p>
+        </p:txBody>
+      </p:sp>
+      <p:sp>
+        <p:nvSpPr>
+          <p:cNvPr id="9" name="role">
+            <a:extLst>
+              <a:ext uri="{FF2B5EF4-FFF2-40B4-BE49-F238E27FC236}">
+                <ns2:creationId id="{85E3BE7B-257F-4E72-A5B1-9E9324DD4544}"/>
+              </a:ext>
+            </a:extLst>
+          </p:cNvPr>
+          <p:cNvSpPr>
+            <a:spLocks noGrp="1"/>
+          </p:cNvSpPr>
+          <p:nvPr/>
+        </p:nvSpPr>
+        <p:spPr>
+          <a:xfrm>
+            <a:off x="742950" y="3448050"/>
+            <a:ext cx="7143750" cy="647700"/>
+          </a:xfrm>
+          <a:prstGeom prst="rect">
+            <a:avLst/>
+          </a:prstGeom>
+          <a:noFill/>
+          <a:ln w="0">
+            <a:noFill/>
+          </a:ln>
+        </p:spPr>
+        <p:txBody>
+          <a:bodyPr/>
+          <a:lstStyle>
+            <a:defPPr>
+              <a:defRPr sz="1650" b="0">
+                <a:solidFill>
+                  <a:srgbClr val="596579"/>
+                </a:solidFill>
+              </a:defRPr>
+            </a:defPPr>
+            <a:lvl1pPr>
+              <a:buNone/>
+              <a:defRPr sz="1650" b="0">
+                <a:solidFill>
+                  <a:srgbClr val="596579"/>
+                </a:solidFill>
+              </a:defRPr>
+            </a:lvl1pPr>
+            <a:lvl2pPr>
+              <a:buNone/>
+              <a:defRPr sz="1650" b="0">
+                <a:solidFill>
+                  <a:srgbClr val="596579"/>
+                </a:solidFill>
+              </a:defRPr>
+            </a:lvl2pPr>
+            <a:lvl3pPr>
+              <a:buNone/>
+              <a:defRPr sz="1650" b="0">
+                <a:solidFill>
+                  <a:srgbClr val="596579"/>
+                </a:solidFill>
+              </a:defRPr>
+            </a:lvl3pPr>
+            <a:lvl4pPr>
+              <a:buNone/>
+              <a:defRPr sz="1650" b="0">
+                <a:solidFill>
+                  <a:srgbClr val="596579"/>
+                </a:solidFill>
+              </a:defRPr>
+            </a:lvl4pPr>
+            <a:lvl5pPr>
+              <a:buNone/>
+              <a:defRPr sz="1650" b="0">
+                <a:solidFill>
+                  <a:srgbClr val="596579"/>
+                </a:solidFill>
+              </a:defRPr>
+            </a:lvl5pPr>
+            <a:lvl6pPr>
+              <a:buNone/>
+              <a:defRPr sz="1650" b="0">
+                <a:solidFill>
+                  <a:srgbClr val="596579"/>
+                </a:solidFill>
+              </a:defRPr>
+            </a:lvl6pPr>
+            <a:lvl7pPr>
+              <a:buNone/>
+              <a:defRPr sz="1650" b="0">
+                <a:solidFill>
+                  <a:srgbClr val="596579"/>
+                </a:solidFill>
+              </a:defRPr>
+            </a:lvl7pPr>
+            <a:lvl8pPr>
+              <a:buNone/>
+              <a:defRPr sz="1650" b="0">
+                <a:solidFill>
+                  <a:srgbClr val="596579"/>
+                </a:solidFill>
+              </a:defRPr>
+            </a:lvl8pPr>
+            <a:lvl9pPr>
+              <a:buNone/>
+              <a:defRPr sz="1650" b="0">
+                <a:solidFill>
+                  <a:srgbClr val="596579"/>
+                </a:solidFill>
+              </a:defRPr>
+            </a:lvl9pPr>
+          </a:lstStyle>
+          <a:p>
+            <a:pPr>
+              <a:buNone/>
+              <a:defRPr sz="1650" b="0">
+                <a:solidFill>
+                  <a:srgbClr val="596579"/>
+                </a:solidFill>
+              </a:defRPr>
+            </a:pPr>
+            <a:r>
+              <a:rPr sz="1650" b="0">
+                <a:solidFill>
+                  <a:srgbClr val="596579"/>
+                </a:solidFill>
+              </a:rPr>
+              <a:t>기능과 동작 기준을 정하고, AI 에이전트로 구현·테스트 진행</a:t>
+            </a:r>
+          </a:p>
+          <a:p>
+            <a:pPr>
+              <a:buNone/>
+              <a:defRPr sz="1650" b="0">
+                <a:solidFill>
+                  <a:srgbClr val="596579"/>
+                </a:solidFill>
+              </a:defRPr>
+            </a:pPr>
+            <a:r>
+              <a:rPr sz="1650" b="0">
+                <a:solidFill>
+                  <a:srgbClr val="596579"/>
+                </a:solidFill>
+              </a:rPr>
+              <a:t>실제 기기에서 사용하며 화면 표현과 설정 과정의 불편 개선</a:t>
+            </a:r>
+          </a:p>
+        </p:txBody>
+      </p:sp>
+      <p:sp>
+        <p:nvSpPr>
+          <p:cNvPr id="10" name="delivery-label">
+            <a:extLst>
+              <a:ext uri="{FF2B5EF4-FFF2-40B4-BE49-F238E27FC236}">
+                <ns2:creationId id="{416EF1AE-A110-44E0-86FF-5E29A2551952}"/>
+              </a:ext>
+            </a:extLst>
+          </p:cNvPr>
+          <p:cNvSpPr>
+            <a:spLocks noGrp="1"/>
+          </p:cNvSpPr>
+          <p:nvPr/>
+        </p:nvSpPr>
+        <p:spPr>
+          <a:xfrm>
+            <a:off x="742950" y="4438650"/>
+            <a:ext cx="6667500" cy="304800"/>
+          </a:xfrm>
+          <a:prstGeom prst="rect">
+            <a:avLst/>
+          </a:prstGeom>
+          <a:noFill/>
+          <a:ln w="0">
+            <a:noFill/>
+          </a:ln>
+        </p:spPr>
+        <p:txBody>
+          <a:bodyPr/>
+          <a:lstStyle>
+            <a:defPPr>
+              <a:defRPr sz="1725" b="1">
+                <a:solidFill>
+                  <a:srgbClr val="151A25"/>
+                </a:solidFill>
+              </a:defRPr>
+            </a:defPPr>
+            <a:lvl1pPr>
+              <a:buNone/>
+              <a:defRPr sz="1725" b="1">
+                <a:solidFill>
+                  <a:srgbClr val="151A25"/>
+                </a:solidFill>
+              </a:defRPr>
+            </a:lvl1pPr>
+            <a:lvl2pPr>
+              <a:buNone/>
+              <a:defRPr sz="1725" b="1">
+                <a:solidFill>
+                  <a:srgbClr val="151A25"/>
+                </a:solidFill>
+              </a:defRPr>
+            </a:lvl2pPr>
+            <a:lvl3pPr>
+              <a:buNone/>
+              <a:defRPr sz="1725" b="1">
+                <a:solidFill>
+                  <a:srgbClr val="151A25"/>
+                </a:solidFill>
+              </a:defRPr>
+            </a:lvl3pPr>
+            <a:lvl4pPr>
+              <a:buNone/>
+              <a:defRPr sz="1725" b="1">
+                <a:solidFill>
+                  <a:srgbClr val="151A25"/>
+                </a:solidFill>
+              </a:defRPr>
+            </a:lvl4pPr>
+            <a:lvl5pPr>
+              <a:buNone/>
+              <a:defRPr sz="1725" b="1">
+                <a:solidFill>
+                  <a:srgbClr val="151A25"/>
+                </a:solidFill>
+              </a:defRPr>
+            </a:lvl5pPr>
+            <a:lvl6pPr>
+              <a:buNone/>
+              <a:defRPr sz="1725" b="1">
+                <a:solidFill>
+                  <a:srgbClr val="151A25"/>
+                </a:solidFill>
+              </a:defRPr>
+            </a:lvl6pPr>
+            <a:lvl7pPr>
+              <a:buNone/>
+              <a:defRPr sz="1725" b="1">
+                <a:solidFill>
+                  <a:srgbClr val="151A25"/>
+                </a:solidFill>
+              </a:defRPr>
+            </a:lvl7pPr>
+            <a:lvl8pPr>
+              <a:buNone/>
+              <a:defRPr sz="1725" b="1">
+                <a:solidFill>
+                  <a:srgbClr val="151A25"/>
+                </a:solidFill>
+              </a:defRPr>
+            </a:lvl8pPr>
+            <a:lvl9pPr>
+              <a:buNone/>
+              <a:defRPr sz="1725" b="1">
+                <a:solidFill>
+                  <a:srgbClr val="151A25"/>
+                </a:solidFill>
+              </a:defRPr>
+            </a:lvl9pPr>
+          </a:lstStyle>
+          <a:p>
+            <a:pPr>
+              <a:buNone/>
+              <a:defRPr sz="1725" b="1">
+                <a:solidFill>
+                  <a:srgbClr val="151A25"/>
+                </a:solidFill>
+              </a:defRPr>
+            </a:pPr>
+            <a:r>
+              <a:rPr sz="1725" b="1">
+                <a:solidFill>
+                  <a:srgbClr val="151A25"/>
+                </a:solidFill>
+              </a:rPr>
+              <a:t>개발을 제품으로 연결</a:t>
+            </a:r>
+          </a:p>
+        </p:txBody>
+      </p:sp>
+      <p:sp>
+        <p:nvSpPr>
+          <p:cNvPr id="11" name="delivery">
+            <a:extLst>
+              <a:ext uri="{FF2B5EF4-FFF2-40B4-BE49-F238E27FC236}">
+                <ns2:creationId id="{3230FF20-1EF1-40BC-A8D5-85E66F3BFBB2}"/>
+              </a:ext>
+            </a:extLst>
+          </p:cNvPr>
+          <p:cNvSpPr>
+            <a:spLocks noGrp="1"/>
+          </p:cNvSpPr>
+          <p:nvPr/>
+        </p:nvSpPr>
+        <p:spPr>
+          <a:xfrm>
+            <a:off x="742950" y="4838700"/>
+            <a:ext cx="7143750" cy="914400"/>
+          </a:xfrm>
+          <a:prstGeom prst="rect">
+            <a:avLst/>
+          </a:prstGeom>
+          <a:noFill/>
+          <a:ln w="0">
+            <a:noFill/>
+          </a:ln>
+        </p:spPr>
+        <p:txBody>
+          <a:bodyPr/>
+          <a:lstStyle>
+            <a:defPPr>
+              <a:defRPr sz="1650" b="0">
+                <a:solidFill>
+                  <a:srgbClr val="596579"/>
+                </a:solidFill>
+              </a:defRPr>
+            </a:defPPr>
+            <a:lvl1pPr>
+              <a:buNone/>
+              <a:defRPr sz="1650" b="0">
+                <a:solidFill>
+                  <a:srgbClr val="596579"/>
+                </a:solidFill>
+              </a:defRPr>
+            </a:lvl1pPr>
+            <a:lvl2pPr>
+              <a:buNone/>
+              <a:defRPr sz="1650" b="0">
+                <a:solidFill>
+                  <a:srgbClr val="596579"/>
+                </a:solidFill>
+              </a:defRPr>
+            </a:lvl2pPr>
+            <a:lvl3pPr>
+              <a:buNone/>
+              <a:defRPr sz="1650" b="0">
+                <a:solidFill>
+                  <a:srgbClr val="596579"/>
+                </a:solidFill>
+              </a:defRPr>
+            </a:lvl3pPr>
+            <a:lvl4pPr>
+              <a:buNone/>
+              <a:defRPr sz="1650" b="0">
+                <a:solidFill>
+                  <a:srgbClr val="596579"/>
+                </a:solidFill>
+              </a:defRPr>
+            </a:lvl4pPr>
+            <a:lvl5pPr>
+              <a:buNone/>
+              <a:defRPr sz="1650" b="0">
+                <a:solidFill>
+                  <a:srgbClr val="596579"/>
+                </a:solidFill>
+              </a:defRPr>
+            </a:lvl5pPr>
+            <a:lvl6pPr>
+              <a:buNone/>
+              <a:defRPr sz="1650" b="0">
+                <a:solidFill>
+                  <a:srgbClr val="596579"/>
+                </a:solidFill>
+              </a:defRPr>
+            </a:lvl6pPr>
+            <a:lvl7pPr>
+              <a:buNone/>
+              <a:defRPr sz="1650" b="0">
+                <a:solidFill>
+                  <a:srgbClr val="596579"/>
+                </a:solidFill>
+              </a:defRPr>
+            </a:lvl7pPr>
+            <a:lvl8pPr>
+              <a:buNone/>
+              <a:defRPr sz="1650" b="0">
+                <a:solidFill>
+                  <a:srgbClr val="596579"/>
+                </a:solidFill>
+              </a:defRPr>
+            </a:lvl8pPr>
+            <a:lvl9pPr>
+              <a:buNone/>
+              <a:defRPr sz="1650" b="0">
+                <a:solidFill>
+                  <a:srgbClr val="596579"/>
+                </a:solidFill>
+              </a:defRPr>
+            </a:lvl9pPr>
+          </a:lstStyle>
+          <a:p>
+            <a:pPr>
+              <a:buNone/>
+              <a:defRPr sz="1650" b="0">
+                <a:solidFill>
+                  <a:srgbClr val="596579"/>
+                </a:solidFill>
+              </a:defRPr>
+            </a:pPr>
+            <a:r>
+              <a:rPr sz="1650" b="0">
+                <a:solidFill>
+                  <a:srgbClr val="596579"/>
+                </a:solidFill>
+              </a:rPr>
+              <a:t>요구사항·결정·검증 기록을 하네스로 관리</a:t>
+            </a:r>
+          </a:p>
+          <a:p>
+            <a:pPr>
+              <a:buNone/>
+              <a:defRPr sz="1650" b="0">
+                <a:solidFill>
+                  <a:srgbClr val="596579"/>
+                </a:solidFill>
+              </a:defRPr>
+            </a:pPr>
+            <a:r>
+              <a:rPr sz="1650" b="0">
+                <a:solidFill>
+                  <a:srgbClr val="596579"/>
+                </a:solidFill>
+              </a:rPr>
+              <a:t>설치·권한 안내와 개인정보처리방침을 준비해 출시</a:t>
+            </a:r>
+          </a:p>
+          <a:p>
+            <a:pPr>
+              <a:buNone/>
+              <a:defRPr sz="1650" b="0">
+                <a:solidFill>
+                  <a:srgbClr val="596579"/>
+                </a:solidFill>
+              </a:defRPr>
+            </a:pPr>
+            <a:r>
+              <a:rPr sz="1650" b="0">
+                <a:solidFill>
+                  <a:srgbClr val="596579"/>
+                </a:solidFill>
+              </a:rPr>
+              <a:t>출시 후 직접 사용하며 발견한 문제를 수정</a:t>
+            </a:r>
+          </a:p>
+        </p:txBody>
+      </p:sp>
+      <p:pic>
+        <p:nvPicPr>
+          <p:cNvPr id="12" name="">
+            <a:extLst>
+              <a:ext uri="{FF2B5EF4-FFF2-40B4-BE49-F238E27FC236}">
+                <ns2:creationId id="{179FCDE8-FFFC-4BB2-8186-FC98CD4BEF04}"/>
+              </a:ext>
+            </a:extLst>
+          </p:cNvPr>
+          <p:cNvPicPr>
+            <a:picLocks noChangeAspect="1"/>
+          </p:cNvPicPr>
+          <p:nvPr/>
+        </p:nvPicPr>
+        <p:blipFill>
+          <a:blip r:embed="Rd2c065fe9b9049bd"/>
+          <a:stretch/>
+        </p:blipFill>
+        <p:spPr>
+          <a:xfrm>
+            <a:off x="9658350" y="2133600"/>
+            <a:ext cx="1924050" cy="3429000"/>
+          </a:xfrm>
+          <a:prstGeom prst="rect">
+            <a:avLst/>
+          </a:prstGeom>
+        </p:spPr>
+      </p:pic>
+      <p:sp>
+        <p:nvSpPr>
+          <p:cNvPr id="13" name="image-caption">
+            <a:extLst>
+              <a:ext uri="{FF2B5EF4-FFF2-40B4-BE49-F238E27FC236}">
+                <ns2:creationId id="{FF0D5A1C-3281-4A2C-9504-84756690C6CF}"/>
+              </a:ext>
+            </a:extLst>
+          </p:cNvPr>
+          <p:cNvSpPr>
+            <a:spLocks noGrp="1"/>
+          </p:cNvSpPr>
+          <p:nvPr/>
+        </p:nvSpPr>
+        <p:spPr>
+          <a:xfrm>
+            <a:off x="7620000" y="5715000"/>
+            <a:ext cx="4000500" cy="228600"/>
+          </a:xfrm>
+          <a:prstGeom prst="rect">
+            <a:avLst/>
+          </a:prstGeom>
+          <a:noFill/>
+          <a:ln w="0">
+            <a:noFill/>
+          </a:ln>
+        </p:spPr>
+        <p:txBody>
+          <a:bodyPr/>
+          <a:lstStyle>
+            <a:defPPr>
+              <a:defRPr sz="975" b="0">
+                <a:solidFill>
+                  <a:srgbClr val="596579"/>
+                </a:solidFill>
+              </a:defRPr>
+            </a:defPPr>
+            <a:lvl1pPr>
+              <a:buNone/>
+              <a:defRPr sz="975" b="0">
+                <a:solidFill>
+                  <a:srgbClr val="596579"/>
+                </a:solidFill>
+              </a:defRPr>
+            </a:lvl1pPr>
+            <a:lvl2pPr>
+              <a:buNone/>
+              <a:defRPr sz="975" b="0">
+                <a:solidFill>
+                  <a:srgbClr val="596579"/>
+                </a:solidFill>
+              </a:defRPr>
+            </a:lvl2pPr>
+            <a:lvl3pPr>
+              <a:buNone/>
+              <a:defRPr sz="975" b="0">
+                <a:solidFill>
+                  <a:srgbClr val="596579"/>
+                </a:solidFill>
+              </a:defRPr>
+            </a:lvl3pPr>
+            <a:lvl4pPr>
+              <a:buNone/>
+              <a:defRPr sz="975" b="0">
+                <a:solidFill>
+                  <a:srgbClr val="596579"/>
+                </a:solidFill>
+              </a:defRPr>
+            </a:lvl4pPr>
+            <a:lvl5pPr>
+              <a:buNone/>
+              <a:defRPr sz="975" b="0">
+                <a:solidFill>
+                  <a:srgbClr val="596579"/>
+                </a:solidFill>
+              </a:defRPr>
+            </a:lvl5pPr>
+            <a:lvl6pPr>
+              <a:buNone/>
+              <a:defRPr sz="975" b="0">
+                <a:solidFill>
+                  <a:srgbClr val="596579"/>
+                </a:solidFill>
+              </a:defRPr>
+            </a:lvl6pPr>
+            <a:lvl7pPr>
+              <a:buNone/>
+              <a:defRPr sz="975" b="0">
+                <a:solidFill>
+                  <a:srgbClr val="596579"/>
+                </a:solidFill>
+              </a:defRPr>
+            </a:lvl7pPr>
+            <a:lvl8pPr>
+              <a:buNone/>
+              <a:defRPr sz="975" b="0">
+                <a:solidFill>
+                  <a:srgbClr val="596579"/>
+                </a:solidFill>
+              </a:defRPr>
+            </a:lvl8pPr>
+            <a:lvl9pPr>
+              <a:buNone/>
+              <a:defRPr sz="975" b="0">
+                <a:solidFill>
+                  <a:srgbClr val="596579"/>
+                </a:solidFill>
+              </a:defRPr>
+            </a:lvl9pPr>
+          </a:lstStyle>
+          <a:p>
+            <a:pPr>
+              <a:buNone/>
+              <a:defRPr sz="975" b="0">
+                <a:solidFill>
+                  <a:srgbClr val="596579"/>
+                </a:solidFill>
+              </a:defRPr>
+            </a:pPr>
+            <a:r>
+              <a:rPr sz="975" b="0">
+                <a:solidFill>
+                  <a:srgbClr val="596579"/>
+                </a:solidFill>
+              </a:rPr>
+              <a:t>폴드 (왼쪽) · 플립 (오른쪽) 효과 예시</a:t>
+            </a:r>
+          </a:p>
+        </p:txBody>
+      </p:sp>
+      <p:sp>
+        <p:nvSpPr>
+          <p:cNvPr id="14" name="footer-rule">
+            <a:extLst>
+              <a:ext uri="{FF2B5EF4-FFF2-40B4-BE49-F238E27FC236}">
+                <ns2:creationId id="{915E5E52-C68B-43AF-AB4A-3200A9235440}"/>
+              </a:ext>
+            </a:extLst>
+          </p:cNvPr>
+          <p:cNvSpPr>
+            <a:spLocks noGrp="1"/>
+          </p:cNvSpPr>
+          <p:nvPr/>
+        </p:nvSpPr>
+        <p:spPr>
+          <a:xfrm>
+            <a:off x="647700" y="6496050"/>
+            <a:ext cx="10896600" cy="9525"/>
+          </a:xfrm>
+          <a:prstGeom prst="rect">
+            <a:avLst/>
+          </a:prstGeom>
+          <a:solidFill>
+            <a:srgbClr val="D5DDE8"/>
+          </a:solidFill>
+          <a:ln w="0">
+            <a:noFill/>
+          </a:ln>
+        </p:spPr>
+      </p:sp>
+      <p:sp>
+        <p:nvSpPr>
+          <p:cNvPr id="15" name="footer">
+            <a:extLst>
+              <a:ext uri="{FF2B5EF4-FFF2-40B4-BE49-F238E27FC236}">
+                <ns2:creationId id="{6B4C99E7-9A8D-4EA4-9E65-E75020B6E4CE}"/>
+              </a:ext>
+            </a:extLst>
+          </p:cNvPr>
+          <p:cNvSpPr>
+            <a:spLocks noGrp="1"/>
+          </p:cNvSpPr>
+          <p:nvPr/>
+        </p:nvSpPr>
+        <p:spPr>
+          <a:xfrm>
+            <a:off x="742950" y="6629400"/>
+            <a:ext cx="6667500" cy="152400"/>
+          </a:xfrm>
+          <a:prstGeom prst="rect">
+            <a:avLst/>
+          </a:prstGeom>
+          <a:noFill/>
+          <a:ln w="0">
+            <a:noFill/>
+          </a:ln>
+        </p:spPr>
+        <p:txBody>
+          <a:bodyPr/>
+          <a:lstStyle>
+            <a:defPPr>
+              <a:defRPr sz="675" b="0">
+                <a:solidFill>
+                  <a:srgbClr val="94A0B2"/>
+                </a:solidFill>
+              </a:defRPr>
+            </a:defPPr>
+            <a:lvl1pPr>
+              <a:buNone/>
+              <a:defRPr sz="675" b="0">
+                <a:solidFill>
+                  <a:srgbClr val="94A0B2"/>
+                </a:solidFill>
+              </a:defRPr>
+            </a:lvl1pPr>
+            <a:lvl2pPr>
+              <a:buNone/>
+              <a:defRPr sz="675" b="0">
+                <a:solidFill>
+                  <a:srgbClr val="94A0B2"/>
+                </a:solidFill>
+              </a:defRPr>
+            </a:lvl2pPr>
+            <a:lvl3pPr>
+              <a:buNone/>
+              <a:defRPr sz="675" b="0">
+                <a:solidFill>
+                  <a:srgbClr val="94A0B2"/>
+                </a:solidFill>
+              </a:defRPr>
+            </a:lvl3pPr>
+            <a:lvl4pPr>
+              <a:buNone/>
+              <a:defRPr sz="675" b="0">
+                <a:solidFill>
+                  <a:srgbClr val="94A0B2"/>
+                </a:solidFill>
+              </a:defRPr>
+            </a:lvl4pPr>
+            <a:lvl5pPr>
+              <a:buNone/>
+              <a:defRPr sz="675" b="0">
+                <a:solidFill>
+                  <a:srgbClr val="94A0B2"/>
+                </a:solidFill>
+              </a:defRPr>
+            </a:lvl5pPr>
+            <a:lvl6pPr>
+              <a:buNone/>
+              <a:defRPr sz="675" b="0">
+                <a:solidFill>
+                  <a:srgbClr val="94A0B2"/>
+                </a:solidFill>
+              </a:defRPr>
+            </a:lvl6pPr>
+            <a:lvl7pPr>
+              <a:buNone/>
+              <a:defRPr sz="675" b="0">
+                <a:solidFill>
+                  <a:srgbClr val="94A0B2"/>
+                </a:solidFill>
+              </a:defRPr>
+            </a:lvl7pPr>
+            <a:lvl8pPr>
+              <a:buNone/>
+              <a:defRPr sz="675" b="0">
+                <a:solidFill>
+                  <a:srgbClr val="94A0B2"/>
+                </a:solidFill>
+              </a:defRPr>
+            </a:lvl8pPr>
+            <a:lvl9pPr>
+              <a:buNone/>
+              <a:defRPr sz="675" b="0">
+                <a:solidFill>
+                  <a:srgbClr val="94A0B2"/>
+                </a:solidFill>
+              </a:defRPr>
+            </a:lvl9pPr>
+          </a:lstStyle>
+          <a:p>
+            <a:pPr>
+              <a:buNone/>
+              <a:defRPr sz="675" b="0">
+                <a:solidFill>
+                  <a:srgbClr val="94A0B2"/>
+                </a:solidFill>
+              </a:defRPr>
+            </a:pPr>
+            <a:r>
+              <a:rPr sz="675" b="0">
+                <a:solidFill>
+                  <a:srgbClr val="94A0B2"/>
+                </a:solidFill>
+              </a:rPr>
+              <a:t>HEETAE LEE  /  BACKEND ENGINEER</a:t>
+            </a:r>
+          </a:p>
+        </p:txBody>
+      </p:sp>
+      <p:sp>
+        <p:nvSpPr>
+          <p:cNvPr id="16" name="footer-page">
+            <a:extLst>
+              <a:ext uri="{FF2B5EF4-FFF2-40B4-BE49-F238E27FC236}">
+                <ns2:creationId id="{05D41F87-8C0D-4E25-913A-475A0210253A}"/>
+              </a:ext>
+            </a:extLst>
+          </p:cNvPr>
+          <p:cNvSpPr>
+            <a:spLocks noGrp="1"/>
+          </p:cNvSpPr>
+          <p:nvPr/>
+        </p:nvSpPr>
+        <p:spPr>
+          <a:xfrm>
+            <a:off x="11239500" y="6572250"/>
+            <a:ext cx="381000" cy="228600"/>
+          </a:xfrm>
+          <a:prstGeom prst="rect">
+            <a:avLst/>
+          </a:prstGeom>
+          <a:noFill/>
+          <a:ln w="0">
+            <a:noFill/>
+          </a:ln>
+        </p:spPr>
+        <p:txBody>
+          <a:bodyPr/>
+          <a:lstStyle>
+            <a:defPPr>
+              <a:defRPr sz="675" b="0">
+                <a:solidFill>
+                  <a:srgbClr val="94A0B2"/>
+                </a:solidFill>
+              </a:defRPr>
+            </a:defPPr>
+            <a:lvl1pPr>
+              <a:buNone/>
+              <a:defRPr sz="675" b="0">
+                <a:solidFill>
+                  <a:srgbClr val="94A0B2"/>
+                </a:solidFill>
+              </a:defRPr>
+            </a:lvl1pPr>
+            <a:lvl2pPr>
+              <a:buNone/>
+              <a:defRPr sz="675" b="0">
+                <a:solidFill>
+                  <a:srgbClr val="94A0B2"/>
+                </a:solidFill>
+              </a:defRPr>
+            </a:lvl2pPr>
+            <a:lvl3pPr>
+              <a:buNone/>
+              <a:defRPr sz="675" b="0">
+                <a:solidFill>
+                  <a:srgbClr val="94A0B2"/>
+                </a:solidFill>
+              </a:defRPr>
+            </a:lvl3pPr>
+            <a:lvl4pPr>
+              <a:buNone/>
+              <a:defRPr sz="675" b="0">
+                <a:solidFill>
+                  <a:srgbClr val="94A0B2"/>
+                </a:solidFill>
+              </a:defRPr>
+            </a:lvl4pPr>
+            <a:lvl5pPr>
+              <a:buNone/>
+              <a:defRPr sz="675" b="0">
+                <a:solidFill>
+                  <a:srgbClr val="94A0B2"/>
+                </a:solidFill>
+              </a:defRPr>
+            </a:lvl5pPr>
+            <a:lvl6pPr>
+              <a:buNone/>
+              <a:defRPr sz="675" b="0">
+                <a:solidFill>
+                  <a:srgbClr val="94A0B2"/>
+                </a:solidFill>
+              </a:defRPr>
+            </a:lvl6pPr>
+            <a:lvl7pPr>
+              <a:buNone/>
+              <a:defRPr sz="675" b="0">
+                <a:solidFill>
+                  <a:srgbClr val="94A0B2"/>
+                </a:solidFill>
+              </a:defRPr>
+            </a:lvl7pPr>
+            <a:lvl8pPr>
+              <a:buNone/>
+              <a:defRPr sz="675" b="0">
+                <a:solidFill>
+                  <a:srgbClr val="94A0B2"/>
+                </a:solidFill>
+              </a:defRPr>
+            </a:lvl8pPr>
+            <a:lvl9pPr>
+              <a:buNone/>
+              <a:defRPr sz="675" b="0">
+                <a:solidFill>
+                  <a:srgbClr val="94A0B2"/>
+                </a:solidFill>
+              </a:defRPr>
+            </a:lvl9pPr>
+          </a:lstStyle>
+          <a:p>
+            <a:pPr>
+              <a:buNone/>
+              <a:defRPr sz="675" b="0">
+                <a:solidFill>
+                  <a:srgbClr val="94A0B2"/>
+                </a:solidFill>
+              </a:defRPr>
+            </a:pPr>
+            <a:r>
+              <a:rPr sz="675" b="0">
+                <a:solidFill>
+                  <a:srgbClr val="94A0B2"/>
+                </a:solidFill>
+              </a:rPr>
+              <a:t>12</a:t>
+            </a:r>
+          </a:p>
+        </p:txBody>
+      </p:sp>
+      <p:pic>
+        <p:nvPicPr>
+          <p:cNvPr id="18" name="">
+            <a:extLst>
+              <a:ext uri="{FF2B5EF4-FFF2-40B4-BE49-F238E27FC236}">
+                <ns2:creationId id="{AD9BA325-4D07-4BC9-B282-5ED08D28CEFC}"/>
+              </a:ext>
+            </a:extLst>
+          </p:cNvPr>
+          <p:cNvPicPr>
+            <a:picLocks noChangeAspect="1"/>
+          </p:cNvPicPr>
+          <p:nvPr/>
+        </p:nvPicPr>
+        <p:blipFill>
+          <a:blip r:embed="Rc6c74533eab44ab6"/>
+          <a:stretch/>
+        </p:blipFill>
+        <p:spPr>
+          <a:xfrm>
+            <a:off x="7620000" y="2137833"/>
+            <a:ext cx="1924050" cy="3420533"/>
+          </a:xfrm>
+          <a:prstGeom prst="rect">
+            <a:avLst/>
+          </a:prstGeom>
+        </p:spPr>
+      </p:pic>
+      <p:pic>
+        <p:nvPicPr>
+          <p:cNvPr id="19" name="" descr="Official Google Play badge">
+            <a:extLst>
+              <a:ext uri="{FF2B5EF4-FFF2-40B4-BE49-F238E27FC236}">
+                <ns2:creationId id="{1CC05FCB-EE87-4E95-9916-416510D13A17}"/>
+              </a:ext>
+            </a:extLst>
+            <a:hlinkClick r:id="rIdGooglePlayApp" tooltip="Duo Flex on Google Play"/>
+          </p:cNvPr>
+          <p:cNvPicPr>
+            <a:picLocks noChangeAspect="1"/>
+          </p:cNvPicPr>
+          <p:nvPr/>
+        </p:nvPicPr>
+        <p:blipFill>
+          <a:blip r:embed="Rd695a974cd45496a"/>
+          <a:stretch/>
+        </p:blipFill>
+        <p:spPr>
+          <a:xfrm>
+            <a:off x="740359" y="5791200"/>
+            <a:ext cx="1624432" cy="628650"/>
+          </a:xfrm>
+          <a:prstGeom prst="rect">
+            <a:avLst/>
+          </a:prstGeom>
+        </p:spPr>
+      </p:pic>
+    </p:spTree>
+    <p:extLst>
+      <p:ext uri="{BB962C8B-B14F-4D97-AF65-F5344CB8AC3E}">
+        <ns4:creationId val="844808624"/>
+      </p:ext>
+    </p:extLst>
+  </p:cSld>
+</p:sld>
+</file>
+
+<file path=ppt/slides/slide13.xml><?xml version="1.0" encoding="utf-8"?>
 <p:sld xmlns:p="http://schemas.openxmlformats.org/presentationml/2006/main">
   <p:cSld>
     <p:bg>
@@ -18864,7 +20849,7 @@
           <p:cNvPr id="47" name="">
             <a:extLst xmlns:a="http://schemas.openxmlformats.org/drawingml/2006/main">
               <a:ext uri="{FF2B5EF4-FFF2-40B4-BE49-F238E27FC236}">
-                <a16:creationId xmlns:a16="http://schemas.microsoft.com/office/drawing/2014/main" id="{08A99509-BC06-4D14-A0C0-0FF0B9573C51}"/>
+                <a16:creationId xmlns:a16="http://schemas.microsoft.com/office/drawing/2014/main" id="{1C5154DF-0FED-41A0-88E3-AB8A39882BB8}"/>
               </a:ext>
             </a:extLst>
           </p:cNvPr>
@@ -18874,7 +20859,7 @@
           <p:nvPr/>
         </p:nvPicPr>
         <p:blipFill>
-          <a:blip xmlns:r="http://schemas.openxmlformats.org/officeDocument/2006/relationships" xmlns:a="http://schemas.openxmlformats.org/drawingml/2006/main" r:embed="Rbf97df3161284e8c"/>
+          <a:blip xmlns:r="http://schemas.openxmlformats.org/officeDocument/2006/relationships" xmlns:a="http://schemas.openxmlformats.org/drawingml/2006/main" r:embed="R7d30f24b0d2b496e"/>
           <a:stretch xmlns:a="http://schemas.openxmlformats.org/drawingml/2006/main"/>
         </p:blipFill>
         <p:spPr>
@@ -18894,7 +20879,7 @@
           <p:cNvPr id="48" name="">
             <a:extLst xmlns:a="http://schemas.openxmlformats.org/drawingml/2006/main">
               <a:ext uri="{FF2B5EF4-FFF2-40B4-BE49-F238E27FC236}">
-                <a16:creationId xmlns:a16="http://schemas.microsoft.com/office/drawing/2014/main" id="{7EBAD545-0980-4B4B-BFB8-E06C83AA6EE7}"/>
+                <a16:creationId xmlns:a16="http://schemas.microsoft.com/office/drawing/2014/main" id="{DA31ADAB-903B-4D3F-9771-7A02EF0FAD80}"/>
               </a:ext>
             </a:extLst>
           </p:cNvPr>
@@ -18904,7 +20889,7 @@
           <p:nvPr/>
         </p:nvPicPr>
         <p:blipFill>
-          <a:blip xmlns:r="http://schemas.openxmlformats.org/officeDocument/2006/relationships" xmlns:a="http://schemas.openxmlformats.org/drawingml/2006/main" r:embed="R88ed0ca364ac47cb"/>
+          <a:blip xmlns:r="http://schemas.openxmlformats.org/officeDocument/2006/relationships" xmlns:a="http://schemas.openxmlformats.org/drawingml/2006/main" r:embed="R734f154629c04b41"/>
           <a:stretch xmlns:a="http://schemas.openxmlformats.org/drawingml/2006/main"/>
         </p:blipFill>
         <p:spPr>
@@ -18924,7 +20909,7 @@
           <p:cNvPr id="49" name="">
             <a:extLst xmlns:a="http://schemas.openxmlformats.org/drawingml/2006/main">
               <a:ext uri="{FF2B5EF4-FFF2-40B4-BE49-F238E27FC236}">
-                <a16:creationId xmlns:a16="http://schemas.microsoft.com/office/drawing/2014/main" id="{F05F375F-FA41-4E03-8C23-A50280869AC0}"/>
+                <a16:creationId xmlns:a16="http://schemas.microsoft.com/office/drawing/2014/main" id="{5584B7B0-D43F-4A35-A5A0-1E99D1DB197F}"/>
               </a:ext>
             </a:extLst>
           </p:cNvPr>
@@ -18934,7 +20919,7 @@
           <p:nvPr/>
         </p:nvPicPr>
         <p:blipFill>
-          <a:blip xmlns:r="http://schemas.openxmlformats.org/officeDocument/2006/relationships" xmlns:a="http://schemas.openxmlformats.org/drawingml/2006/main" r:embed="Rb4a265ccd63845a9"/>
+          <a:blip xmlns:r="http://schemas.openxmlformats.org/officeDocument/2006/relationships" xmlns:a="http://schemas.openxmlformats.org/drawingml/2006/main" r:embed="R97f2be0204bc4523"/>
           <a:stretch xmlns:a="http://schemas.openxmlformats.org/drawingml/2006/main"/>
         </p:blipFill>
         <p:spPr>

</xml_diff>